<commit_message>
feat: decouple backend v2, support standalone local AI via .env, and clean UI
- Load AI API key and model directly from .env with automatic emulator localhost mapping
- Remove mandatory auth redirect to allow full offline-first usage from Home screen
- Clean up markdown heading rendering (###) in AI message bubbles
- Remove obsolete v2 recommendation banner from PantryScreen
- Standardize all screen branding and labels to Cooking Note
- Add source zip creation and document styling scripts

Co-Authored-By: Claude <noreply@anthropic.com>
</commit_message>
<xml_diff>
--- a/docs/THUYET_TRINH_COOKING_NOTE.pptx
+++ b/docs/THUYET_TRINH_COOKING_NOTE.pptx
@@ -5,24 +5,24 @@
     <p:sldMasterId id="2147483648" r:id="rId1"/>
   </p:sldMasterIdLst>
   <p:sldIdLst>
-    <p:sldId id="256" r:id="rId7"/>
-    <p:sldId id="257" r:id="rId8"/>
-    <p:sldId id="258" r:id="rId9"/>
-    <p:sldId id="259" r:id="rId10"/>
-    <p:sldId id="260" r:id="rId11"/>
-    <p:sldId id="261" r:id="rId12"/>
-    <p:sldId id="262" r:id="rId13"/>
-    <p:sldId id="263" r:id="rId14"/>
-    <p:sldId id="264" r:id="rId15"/>
-    <p:sldId id="265" r:id="rId16"/>
-    <p:sldId id="266" r:id="rId17"/>
-    <p:sldId id="267" r:id="rId18"/>
-    <p:sldId id="268" r:id="rId19"/>
-    <p:sldId id="269" r:id="rId20"/>
-    <p:sldId id="270" r:id="rId21"/>
-    <p:sldId id="271" r:id="rId22"/>
+    <p:sldId id="256" r:id="rId2"/>
+    <p:sldId id="257" r:id="rId3"/>
+    <p:sldId id="258" r:id="rId4"/>
+    <p:sldId id="259" r:id="rId5"/>
+    <p:sldId id="260" r:id="rId6"/>
+    <p:sldId id="261" r:id="rId7"/>
+    <p:sldId id="262" r:id="rId8"/>
+    <p:sldId id="263" r:id="rId9"/>
+    <p:sldId id="264" r:id="rId10"/>
+    <p:sldId id="265" r:id="rId11"/>
+    <p:sldId id="266" r:id="rId12"/>
+    <p:sldId id="267" r:id="rId13"/>
+    <p:sldId id="268" r:id="rId14"/>
+    <p:sldId id="269" r:id="rId15"/>
+    <p:sldId id="270" r:id="rId16"/>
+    <p:sldId id="271" r:id="rId17"/>
   </p:sldIdLst>
-  <p:sldSz cx="12191695" cy="6858000" type="screen4x3"/>
+  <p:sldSz cx="12192000" cy="6858000"/>
   <p:notesSz cx="6858000" cy="9144000"/>
   <p:defaultTextStyle>
     <a:defPPr>
@@ -119,6 +119,22 @@
       </a:defRPr>
     </a:lvl9pPr>
   </p:defaultTextStyle>
+  <p:extLst>
+    <p:ext uri="{EFAFB233-063F-42B5-8137-9DF3F51BA10A}">
+      <p15:sldGuideLst xmlns:p15="http://schemas.microsoft.com/office/powerpoint/2012/main">
+        <p15:guide id="1" orient="horz" pos="2160">
+          <p15:clr>
+            <a:srgbClr val="A4A3A4"/>
+          </p15:clr>
+        </p15:guide>
+        <p15:guide id="2" pos="2880">
+          <p15:clr>
+            <a:srgbClr val="A4A3A4"/>
+          </p15:clr>
+        </p15:guide>
+      </p15:sldGuideLst>
+    </p:ext>
+  </p:extLst>
 </p:presentation>
 </file>
 
@@ -160,10 +176,9 @@
           <a:lstStyle/>
           <a:p>
             <a:r>
-              <a:rPr lang="en-US" smtClean="0"/>
+              <a:rPr lang="en-US"/>
               <a:t>Click to edit Master title style</a:t>
             </a:r>
-            <a:endParaRPr lang="en-US"/>
           </a:p>
         </p:txBody>
       </p:sp>
@@ -279,10 +294,9 @@
           </a:lstStyle>
           <a:p>
             <a:r>
-              <a:rPr lang="en-US" smtClean="0"/>
+              <a:rPr lang="en-US"/>
               <a:t>Click to edit Master subtitle style</a:t>
             </a:r>
-            <a:endParaRPr lang="en-US"/>
           </a:p>
         </p:txBody>
       </p:sp>
@@ -303,7 +317,7 @@
           <a:p>
             <a:fld id="{5BCAD085-E8A6-8845-BD4E-CB4CCA059FC4}" type="datetimeFigureOut">
               <a:rPr lang="en-US" smtClean="0"/>
-              <a:t>1/27/13</a:t>
+              <a:t>10/4/2026</a:t>
             </a:fld>
             <a:endParaRPr lang="en-US"/>
           </a:p>
@@ -397,10 +411,9 @@
           <a:lstStyle/>
           <a:p>
             <a:r>
-              <a:rPr lang="en-US" smtClean="0"/>
+              <a:rPr lang="en-US"/>
               <a:t>Click to edit Master title style</a:t>
             </a:r>
-            <a:endParaRPr lang="en-US"/>
           </a:p>
         </p:txBody>
       </p:sp>
@@ -421,38 +434,37 @@
           <a:p>
             <a:pPr lvl="0"/>
             <a:r>
-              <a:rPr lang="en-US" smtClean="0"/>
+              <a:rPr lang="en-US"/>
               <a:t>Click to edit Master text styles</a:t>
             </a:r>
           </a:p>
           <a:p>
             <a:pPr lvl="1"/>
             <a:r>
-              <a:rPr lang="en-US" smtClean="0"/>
+              <a:rPr lang="en-US"/>
               <a:t>Second level</a:t>
             </a:r>
           </a:p>
           <a:p>
             <a:pPr lvl="2"/>
             <a:r>
-              <a:rPr lang="en-US" smtClean="0"/>
+              <a:rPr lang="en-US"/>
               <a:t>Third level</a:t>
             </a:r>
           </a:p>
           <a:p>
             <a:pPr lvl="3"/>
             <a:r>
-              <a:rPr lang="en-US" smtClean="0"/>
+              <a:rPr lang="en-US"/>
               <a:t>Fourth level</a:t>
             </a:r>
           </a:p>
           <a:p>
             <a:pPr lvl="4"/>
             <a:r>
-              <a:rPr lang="en-US" smtClean="0"/>
+              <a:rPr lang="en-US"/>
               <a:t>Fifth level</a:t>
             </a:r>
-            <a:endParaRPr lang="en-US"/>
           </a:p>
         </p:txBody>
       </p:sp>
@@ -473,7 +485,7 @@
           <a:p>
             <a:fld id="{5BCAD085-E8A6-8845-BD4E-CB4CCA059FC4}" type="datetimeFigureOut">
               <a:rPr lang="en-US" smtClean="0"/>
-              <a:t>1/27/13</a:t>
+              <a:t>10/4/2026</a:t>
             </a:fld>
             <a:endParaRPr lang="en-US"/>
           </a:p>
@@ -572,10 +584,9 @@
           <a:lstStyle/>
           <a:p>
             <a:r>
-              <a:rPr lang="en-US" smtClean="0"/>
+              <a:rPr lang="en-US"/>
               <a:t>Click to edit Master title style</a:t>
             </a:r>
-            <a:endParaRPr lang="en-US"/>
           </a:p>
         </p:txBody>
       </p:sp>
@@ -601,38 +612,37 @@
           <a:p>
             <a:pPr lvl="0"/>
             <a:r>
-              <a:rPr lang="en-US" smtClean="0"/>
+              <a:rPr lang="en-US"/>
               <a:t>Click to edit Master text styles</a:t>
             </a:r>
           </a:p>
           <a:p>
             <a:pPr lvl="1"/>
             <a:r>
-              <a:rPr lang="en-US" smtClean="0"/>
+              <a:rPr lang="en-US"/>
               <a:t>Second level</a:t>
             </a:r>
           </a:p>
           <a:p>
             <a:pPr lvl="2"/>
             <a:r>
-              <a:rPr lang="en-US" smtClean="0"/>
+              <a:rPr lang="en-US"/>
               <a:t>Third level</a:t>
             </a:r>
           </a:p>
           <a:p>
             <a:pPr lvl="3"/>
             <a:r>
-              <a:rPr lang="en-US" smtClean="0"/>
+              <a:rPr lang="en-US"/>
               <a:t>Fourth level</a:t>
             </a:r>
           </a:p>
           <a:p>
             <a:pPr lvl="4"/>
             <a:r>
-              <a:rPr lang="en-US" smtClean="0"/>
+              <a:rPr lang="en-US"/>
               <a:t>Fifth level</a:t>
             </a:r>
-            <a:endParaRPr lang="en-US"/>
           </a:p>
         </p:txBody>
       </p:sp>
@@ -653,7 +663,7 @@
           <a:p>
             <a:fld id="{5BCAD085-E8A6-8845-BD4E-CB4CCA059FC4}" type="datetimeFigureOut">
               <a:rPr lang="en-US" smtClean="0"/>
-              <a:t>1/27/13</a:t>
+              <a:t>10/4/2026</a:t>
             </a:fld>
             <a:endParaRPr lang="en-US"/>
           </a:p>
@@ -747,10 +757,9 @@
           <a:lstStyle/>
           <a:p>
             <a:r>
-              <a:rPr lang="en-US" smtClean="0"/>
+              <a:rPr lang="en-US"/>
               <a:t>Click to edit Master title style</a:t>
             </a:r>
-            <a:endParaRPr lang="en-US"/>
           </a:p>
         </p:txBody>
       </p:sp>
@@ -771,38 +780,37 @@
           <a:p>
             <a:pPr lvl="0"/>
             <a:r>
-              <a:rPr lang="en-US" smtClean="0"/>
+              <a:rPr lang="en-US"/>
               <a:t>Click to edit Master text styles</a:t>
             </a:r>
           </a:p>
           <a:p>
             <a:pPr lvl="1"/>
             <a:r>
-              <a:rPr lang="en-US" smtClean="0"/>
+              <a:rPr lang="en-US"/>
               <a:t>Second level</a:t>
             </a:r>
           </a:p>
           <a:p>
             <a:pPr lvl="2"/>
             <a:r>
-              <a:rPr lang="en-US" smtClean="0"/>
+              <a:rPr lang="en-US"/>
               <a:t>Third level</a:t>
             </a:r>
           </a:p>
           <a:p>
             <a:pPr lvl="3"/>
             <a:r>
-              <a:rPr lang="en-US" smtClean="0"/>
+              <a:rPr lang="en-US"/>
               <a:t>Fourth level</a:t>
             </a:r>
           </a:p>
           <a:p>
             <a:pPr lvl="4"/>
             <a:r>
-              <a:rPr lang="en-US" smtClean="0"/>
+              <a:rPr lang="en-US"/>
               <a:t>Fifth level</a:t>
             </a:r>
-            <a:endParaRPr lang="en-US"/>
           </a:p>
         </p:txBody>
       </p:sp>
@@ -823,7 +831,7 @@
           <a:p>
             <a:fld id="{5BCAD085-E8A6-8845-BD4E-CB4CCA059FC4}" type="datetimeFigureOut">
               <a:rPr lang="en-US" smtClean="0"/>
-              <a:t>1/27/13</a:t>
+              <a:t>10/4/2026</a:t>
             </a:fld>
             <a:endParaRPr lang="en-US"/>
           </a:p>
@@ -926,10 +934,9 @@
           </a:lstStyle>
           <a:p>
             <a:r>
-              <a:rPr lang="en-US" smtClean="0"/>
+              <a:rPr lang="en-US"/>
               <a:t>Click to edit Master title style</a:t>
             </a:r>
-            <a:endParaRPr lang="en-US"/>
           </a:p>
         </p:txBody>
       </p:sp>
@@ -1046,7 +1053,7 @@
           <a:p>
             <a:pPr lvl="0"/>
             <a:r>
-              <a:rPr lang="en-US" smtClean="0"/>
+              <a:rPr lang="en-US"/>
               <a:t>Click to edit Master text styles</a:t>
             </a:r>
           </a:p>
@@ -1069,7 +1076,7 @@
           <a:p>
             <a:fld id="{5BCAD085-E8A6-8845-BD4E-CB4CCA059FC4}" type="datetimeFigureOut">
               <a:rPr lang="en-US" smtClean="0"/>
-              <a:t>1/27/13</a:t>
+              <a:t>10/4/2026</a:t>
             </a:fld>
             <a:endParaRPr lang="en-US"/>
           </a:p>
@@ -1163,10 +1170,9 @@
           <a:lstStyle/>
           <a:p>
             <a:r>
-              <a:rPr lang="en-US" smtClean="0"/>
+              <a:rPr lang="en-US"/>
               <a:t>Click to edit Master title style</a:t>
             </a:r>
-            <a:endParaRPr lang="en-US"/>
           </a:p>
         </p:txBody>
       </p:sp>
@@ -1220,38 +1226,37 @@
           <a:p>
             <a:pPr lvl="0"/>
             <a:r>
-              <a:rPr lang="en-US" smtClean="0"/>
+              <a:rPr lang="en-US"/>
               <a:t>Click to edit Master text styles</a:t>
             </a:r>
           </a:p>
           <a:p>
             <a:pPr lvl="1"/>
             <a:r>
-              <a:rPr lang="en-US" smtClean="0"/>
+              <a:rPr lang="en-US"/>
               <a:t>Second level</a:t>
             </a:r>
           </a:p>
           <a:p>
             <a:pPr lvl="2"/>
             <a:r>
-              <a:rPr lang="en-US" smtClean="0"/>
+              <a:rPr lang="en-US"/>
               <a:t>Third level</a:t>
             </a:r>
           </a:p>
           <a:p>
             <a:pPr lvl="3"/>
             <a:r>
-              <a:rPr lang="en-US" smtClean="0"/>
+              <a:rPr lang="en-US"/>
               <a:t>Fourth level</a:t>
             </a:r>
           </a:p>
           <a:p>
             <a:pPr lvl="4"/>
             <a:r>
-              <a:rPr lang="en-US" smtClean="0"/>
+              <a:rPr lang="en-US"/>
               <a:t>Fifth level</a:t>
             </a:r>
-            <a:endParaRPr lang="en-US"/>
           </a:p>
         </p:txBody>
       </p:sp>
@@ -1305,38 +1310,37 @@
           <a:p>
             <a:pPr lvl="0"/>
             <a:r>
-              <a:rPr lang="en-US" smtClean="0"/>
+              <a:rPr lang="en-US"/>
               <a:t>Click to edit Master text styles</a:t>
             </a:r>
           </a:p>
           <a:p>
             <a:pPr lvl="1"/>
             <a:r>
-              <a:rPr lang="en-US" smtClean="0"/>
+              <a:rPr lang="en-US"/>
               <a:t>Second level</a:t>
             </a:r>
           </a:p>
           <a:p>
             <a:pPr lvl="2"/>
             <a:r>
-              <a:rPr lang="en-US" smtClean="0"/>
+              <a:rPr lang="en-US"/>
               <a:t>Third level</a:t>
             </a:r>
           </a:p>
           <a:p>
             <a:pPr lvl="3"/>
             <a:r>
-              <a:rPr lang="en-US" smtClean="0"/>
+              <a:rPr lang="en-US"/>
               <a:t>Fourth level</a:t>
             </a:r>
           </a:p>
           <a:p>
             <a:pPr lvl="4"/>
             <a:r>
-              <a:rPr lang="en-US" smtClean="0"/>
+              <a:rPr lang="en-US"/>
               <a:t>Fifth level</a:t>
             </a:r>
-            <a:endParaRPr lang="en-US"/>
           </a:p>
         </p:txBody>
       </p:sp>
@@ -1357,7 +1361,7 @@
           <a:p>
             <a:fld id="{5BCAD085-E8A6-8845-BD4E-CB4CCA059FC4}" type="datetimeFigureOut">
               <a:rPr lang="en-US" smtClean="0"/>
-              <a:t>1/27/13</a:t>
+              <a:t>10/4/2026</a:t>
             </a:fld>
             <a:endParaRPr lang="en-US"/>
           </a:p>
@@ -1455,10 +1459,9 @@
           </a:lstStyle>
           <a:p>
             <a:r>
-              <a:rPr lang="en-US" smtClean="0"/>
+              <a:rPr lang="en-US"/>
               <a:t>Click to edit Master title style</a:t>
             </a:r>
-            <a:endParaRPr lang="en-US"/>
           </a:p>
         </p:txBody>
       </p:sp>
@@ -1521,7 +1524,7 @@
           <a:p>
             <a:pPr lvl="0"/>
             <a:r>
-              <a:rPr lang="en-US" smtClean="0"/>
+              <a:rPr lang="en-US"/>
               <a:t>Click to edit Master text styles</a:t>
             </a:r>
           </a:p>
@@ -1577,38 +1580,37 @@
           <a:p>
             <a:pPr lvl="0"/>
             <a:r>
-              <a:rPr lang="en-US" smtClean="0"/>
+              <a:rPr lang="en-US"/>
               <a:t>Click to edit Master text styles</a:t>
             </a:r>
           </a:p>
           <a:p>
             <a:pPr lvl="1"/>
             <a:r>
-              <a:rPr lang="en-US" smtClean="0"/>
+              <a:rPr lang="en-US"/>
               <a:t>Second level</a:t>
             </a:r>
           </a:p>
           <a:p>
             <a:pPr lvl="2"/>
             <a:r>
-              <a:rPr lang="en-US" smtClean="0"/>
+              <a:rPr lang="en-US"/>
               <a:t>Third level</a:t>
             </a:r>
           </a:p>
           <a:p>
             <a:pPr lvl="3"/>
             <a:r>
-              <a:rPr lang="en-US" smtClean="0"/>
+              <a:rPr lang="en-US"/>
               <a:t>Fourth level</a:t>
             </a:r>
           </a:p>
           <a:p>
             <a:pPr lvl="4"/>
             <a:r>
-              <a:rPr lang="en-US" smtClean="0"/>
+              <a:rPr lang="en-US"/>
               <a:t>Fifth level</a:t>
             </a:r>
-            <a:endParaRPr lang="en-US"/>
           </a:p>
         </p:txBody>
       </p:sp>
@@ -1671,7 +1673,7 @@
           <a:p>
             <a:pPr lvl="0"/>
             <a:r>
-              <a:rPr lang="en-US" smtClean="0"/>
+              <a:rPr lang="en-US"/>
               <a:t>Click to edit Master text styles</a:t>
             </a:r>
           </a:p>
@@ -1727,38 +1729,37 @@
           <a:p>
             <a:pPr lvl="0"/>
             <a:r>
-              <a:rPr lang="en-US" smtClean="0"/>
+              <a:rPr lang="en-US"/>
               <a:t>Click to edit Master text styles</a:t>
             </a:r>
           </a:p>
           <a:p>
             <a:pPr lvl="1"/>
             <a:r>
-              <a:rPr lang="en-US" smtClean="0"/>
+              <a:rPr lang="en-US"/>
               <a:t>Second level</a:t>
             </a:r>
           </a:p>
           <a:p>
             <a:pPr lvl="2"/>
             <a:r>
-              <a:rPr lang="en-US" smtClean="0"/>
+              <a:rPr lang="en-US"/>
               <a:t>Third level</a:t>
             </a:r>
           </a:p>
           <a:p>
             <a:pPr lvl="3"/>
             <a:r>
-              <a:rPr lang="en-US" smtClean="0"/>
+              <a:rPr lang="en-US"/>
               <a:t>Fourth level</a:t>
             </a:r>
           </a:p>
           <a:p>
             <a:pPr lvl="4"/>
             <a:r>
-              <a:rPr lang="en-US" smtClean="0"/>
+              <a:rPr lang="en-US"/>
               <a:t>Fifth level</a:t>
             </a:r>
-            <a:endParaRPr lang="en-US"/>
           </a:p>
         </p:txBody>
       </p:sp>
@@ -1779,7 +1780,7 @@
           <a:p>
             <a:fld id="{5BCAD085-E8A6-8845-BD4E-CB4CCA059FC4}" type="datetimeFigureOut">
               <a:rPr lang="en-US" smtClean="0"/>
-              <a:t>1/27/13</a:t>
+              <a:t>10/4/2026</a:t>
             </a:fld>
             <a:endParaRPr lang="en-US"/>
           </a:p>
@@ -1873,10 +1874,9 @@
           <a:lstStyle/>
           <a:p>
             <a:r>
-              <a:rPr lang="en-US" smtClean="0"/>
+              <a:rPr lang="en-US"/>
               <a:t>Click to edit Master title style</a:t>
             </a:r>
-            <a:endParaRPr lang="en-US"/>
           </a:p>
         </p:txBody>
       </p:sp>
@@ -1897,7 +1897,7 @@
           <a:p>
             <a:fld id="{5BCAD085-E8A6-8845-BD4E-CB4CCA059FC4}" type="datetimeFigureOut">
               <a:rPr lang="en-US" smtClean="0"/>
-              <a:t>1/27/13</a:t>
+              <a:t>10/4/2026</a:t>
             </a:fld>
             <a:endParaRPr lang="en-US"/>
           </a:p>
@@ -1992,7 +1992,7 @@
           <a:p>
             <a:fld id="{5BCAD085-E8A6-8845-BD4E-CB4CCA059FC4}" type="datetimeFigureOut">
               <a:rPr lang="en-US" smtClean="0"/>
-              <a:t>1/27/13</a:t>
+              <a:t>10/4/2026</a:t>
             </a:fld>
             <a:endParaRPr lang="en-US"/>
           </a:p>
@@ -2095,10 +2095,9 @@
           </a:lstStyle>
           <a:p>
             <a:r>
-              <a:rPr lang="en-US" smtClean="0"/>
+              <a:rPr lang="en-US"/>
               <a:t>Click to edit Master title style</a:t>
             </a:r>
-            <a:endParaRPr lang="en-US"/>
           </a:p>
         </p:txBody>
       </p:sp>
@@ -2152,38 +2151,37 @@
           <a:p>
             <a:pPr lvl="0"/>
             <a:r>
-              <a:rPr lang="en-US" smtClean="0"/>
+              <a:rPr lang="en-US"/>
               <a:t>Click to edit Master text styles</a:t>
             </a:r>
           </a:p>
           <a:p>
             <a:pPr lvl="1"/>
             <a:r>
-              <a:rPr lang="en-US" smtClean="0"/>
+              <a:rPr lang="en-US"/>
               <a:t>Second level</a:t>
             </a:r>
           </a:p>
           <a:p>
             <a:pPr lvl="2"/>
             <a:r>
-              <a:rPr lang="en-US" smtClean="0"/>
+              <a:rPr lang="en-US"/>
               <a:t>Third level</a:t>
             </a:r>
           </a:p>
           <a:p>
             <a:pPr lvl="3"/>
             <a:r>
-              <a:rPr lang="en-US" smtClean="0"/>
+              <a:rPr lang="en-US"/>
               <a:t>Fourth level</a:t>
             </a:r>
           </a:p>
           <a:p>
             <a:pPr lvl="4"/>
             <a:r>
-              <a:rPr lang="en-US" smtClean="0"/>
+              <a:rPr lang="en-US"/>
               <a:t>Fifth level</a:t>
             </a:r>
-            <a:endParaRPr lang="en-US"/>
           </a:p>
         </p:txBody>
       </p:sp>
@@ -2246,7 +2244,7 @@
           <a:p>
             <a:pPr lvl="0"/>
             <a:r>
-              <a:rPr lang="en-US" smtClean="0"/>
+              <a:rPr lang="en-US"/>
               <a:t>Click to edit Master text styles</a:t>
             </a:r>
           </a:p>
@@ -2269,7 +2267,7 @@
           <a:p>
             <a:fld id="{5BCAD085-E8A6-8845-BD4E-CB4CCA059FC4}" type="datetimeFigureOut">
               <a:rPr lang="en-US" smtClean="0"/>
-              <a:t>1/27/13</a:t>
+              <a:t>10/4/2026</a:t>
             </a:fld>
             <a:endParaRPr lang="en-US"/>
           </a:p>
@@ -2372,10 +2370,9 @@
           </a:lstStyle>
           <a:p>
             <a:r>
-              <a:rPr lang="en-US" smtClean="0"/>
+              <a:rPr lang="en-US"/>
               <a:t>Click to edit Master title style</a:t>
             </a:r>
-            <a:endParaRPr lang="en-US"/>
           </a:p>
         </p:txBody>
       </p:sp>
@@ -2499,7 +2496,7 @@
           <a:p>
             <a:pPr lvl="0"/>
             <a:r>
-              <a:rPr lang="en-US" smtClean="0"/>
+              <a:rPr lang="en-US"/>
               <a:t>Click to edit Master text styles</a:t>
             </a:r>
           </a:p>
@@ -2522,7 +2519,7 @@
           <a:p>
             <a:fld id="{5BCAD085-E8A6-8845-BD4E-CB4CCA059FC4}" type="datetimeFigureOut">
               <a:rPr lang="en-US" smtClean="0"/>
-              <a:t>1/27/13</a:t>
+              <a:t>10/4/2026</a:t>
             </a:fld>
             <a:endParaRPr lang="en-US"/>
           </a:p>
@@ -2631,10 +2628,9 @@
           <a:lstStyle/>
           <a:p>
             <a:r>
-              <a:rPr lang="en-US" smtClean="0"/>
+              <a:rPr lang="en-US"/>
               <a:t>Click to edit Master title style</a:t>
             </a:r>
-            <a:endParaRPr lang="en-US"/>
           </a:p>
         </p:txBody>
       </p:sp>
@@ -2665,38 +2661,37 @@
           <a:p>
             <a:pPr lvl="0"/>
             <a:r>
-              <a:rPr lang="en-US" smtClean="0"/>
+              <a:rPr lang="en-US"/>
               <a:t>Click to edit Master text styles</a:t>
             </a:r>
           </a:p>
           <a:p>
             <a:pPr lvl="1"/>
             <a:r>
-              <a:rPr lang="en-US" smtClean="0"/>
+              <a:rPr lang="en-US"/>
               <a:t>Second level</a:t>
             </a:r>
           </a:p>
           <a:p>
             <a:pPr lvl="2"/>
             <a:r>
-              <a:rPr lang="en-US" smtClean="0"/>
+              <a:rPr lang="en-US"/>
               <a:t>Third level</a:t>
             </a:r>
           </a:p>
           <a:p>
             <a:pPr lvl="3"/>
             <a:r>
-              <a:rPr lang="en-US" smtClean="0"/>
+              <a:rPr lang="en-US"/>
               <a:t>Fourth level</a:t>
             </a:r>
           </a:p>
           <a:p>
             <a:pPr lvl="4"/>
             <a:r>
-              <a:rPr lang="en-US" smtClean="0"/>
+              <a:rPr lang="en-US"/>
               <a:t>Fifth level</a:t>
             </a:r>
-            <a:endParaRPr lang="en-US"/>
           </a:p>
         </p:txBody>
       </p:sp>
@@ -2735,7 +2730,7 @@
           <a:p>
             <a:fld id="{5BCAD085-E8A6-8845-BD4E-CB4CCA059FC4}" type="datetimeFigureOut">
               <a:rPr lang="en-US" smtClean="0"/>
-              <a:t>1/27/13</a:t>
+              <a:t>10/4/2026</a:t>
             </a:fld>
             <a:endParaRPr lang="en-US"/>
           </a:p>
@@ -3094,7 +3089,7 @@
 </file>
 
 <file path=ppt/slides/slide1.xml><?xml version="1.0" encoding="utf-8"?>
-<p:sld xmlns:a="http://schemas.openxmlformats.org/drawingml/2006/main" xmlns:p="http://schemas.openxmlformats.org/presentationml/2006/main" xmlns:r="http://schemas.openxmlformats.org/officeDocument/2006/relationships">
+<p:sld xmlns:a="http://schemas.openxmlformats.org/drawingml/2006/main" xmlns:r="http://schemas.openxmlformats.org/officeDocument/2006/relationships" xmlns:p="http://schemas.openxmlformats.org/presentationml/2006/main">
   <p:cSld>
     <p:spTree>
       <p:nvGrpSpPr>
@@ -3102,7 +3097,14 @@
         <p:cNvGrpSpPr/>
         <p:nvPr/>
       </p:nvGrpSpPr>
-      <p:grpSpPr/>
+      <p:grpSpPr>
+        <a:xfrm>
+          <a:off x="0" y="0"/>
+          <a:ext cx="0" cy="0"/>
+          <a:chOff x="0" y="0"/>
+          <a:chExt cx="0" cy="0"/>
+        </a:xfrm>
+      </p:grpSpPr>
       <p:sp>
         <p:nvSpPr>
           <p:cNvPr id="2" name="Rectangle 1"/>
@@ -3143,6 +3145,7 @@
           <a:lstStyle/>
           <a:p>
             <a:pPr algn="ctr"/>
+            <a:endParaRPr/>
           </a:p>
         </p:txBody>
       </p:sp>
@@ -3186,6 +3189,7 @@
           <a:lstStyle/>
           <a:p>
             <a:pPr algn="ctr"/>
+            <a:endParaRPr/>
           </a:p>
         </p:txBody>
       </p:sp>
@@ -3315,6 +3319,7 @@
           <a:lstStyle/>
           <a:p>
             <a:pPr algn="ctr"/>
+            <a:endParaRPr/>
           </a:p>
         </p:txBody>
       </p:sp>
@@ -3327,7 +3332,7 @@
         <p:spPr>
           <a:xfrm>
             <a:off x="1920240" y="3657600"/>
-            <a:ext cx="8351215" cy="2377440"/>
+            <a:ext cx="8351215" cy="1482457"/>
           </a:xfrm>
           <a:prstGeom prst="rect">
             <a:avLst/>
@@ -3351,7 +3356,44 @@
               </a:defRPr>
             </a:pPr>
             <a:r>
-              <a:t>Giảng viên hướng dẫn:  ThS. Lê Văn Quân</a:t>
+              <a:rPr dirty="0" err="1"/>
+              <a:t>Giảng</a:t>
+            </a:r>
+            <a:r>
+              <a:rPr dirty="0"/>
+              <a:t> </a:t>
+            </a:r>
+            <a:r>
+              <a:rPr dirty="0" err="1"/>
+              <a:t>viên</a:t>
+            </a:r>
+            <a:r>
+              <a:rPr dirty="0"/>
+              <a:t> </a:t>
+            </a:r>
+            <a:r>
+              <a:rPr dirty="0" err="1"/>
+              <a:t>hướng</a:t>
+            </a:r>
+            <a:r>
+              <a:rPr dirty="0"/>
+              <a:t> </a:t>
+            </a:r>
+            <a:r>
+              <a:rPr dirty="0" err="1"/>
+              <a:t>dẫn</a:t>
+            </a:r>
+            <a:r>
+              <a:rPr dirty="0"/>
+              <a:t>:  </a:t>
+            </a:r>
+            <a:r>
+              <a:rPr dirty="0" err="1"/>
+              <a:t>ThS</a:t>
+            </a:r>
+            <a:r>
+              <a:rPr dirty="0"/>
+              <a:t>. Lê Văn Quân</a:t>
             </a:r>
           </a:p>
           <a:p>
@@ -3366,7 +3408,52 @@
               </a:defRPr>
             </a:pPr>
             <a:r>
-              <a:t>Nhóm sinh viên thực hiện — Lớp TT602-K16LT:</a:t>
+              <a:rPr dirty="0" err="1"/>
+              <a:t>Nhóm</a:t>
+            </a:r>
+            <a:r>
+              <a:rPr dirty="0"/>
+              <a:t> </a:t>
+            </a:r>
+            <a:r>
+              <a:rPr dirty="0" err="1"/>
+              <a:t>sinh</a:t>
+            </a:r>
+            <a:r>
+              <a:rPr dirty="0"/>
+              <a:t> </a:t>
+            </a:r>
+            <a:r>
+              <a:rPr dirty="0" err="1"/>
+              <a:t>viên</a:t>
+            </a:r>
+            <a:r>
+              <a:rPr dirty="0"/>
+              <a:t> </a:t>
+            </a:r>
+            <a:r>
+              <a:rPr dirty="0" err="1"/>
+              <a:t>thực</a:t>
+            </a:r>
+            <a:r>
+              <a:rPr dirty="0"/>
+              <a:t> </a:t>
+            </a:r>
+            <a:r>
+              <a:rPr dirty="0" err="1"/>
+              <a:t>hiện</a:t>
+            </a:r>
+            <a:r>
+              <a:rPr dirty="0"/>
+              <a:t> — </a:t>
+            </a:r>
+            <a:r>
+              <a:rPr dirty="0" err="1"/>
+              <a:t>Lớp</a:t>
+            </a:r>
+            <a:r>
+              <a:rPr dirty="0"/>
+              <a:t> TT602-K16LT:</a:t>
             </a:r>
           </a:p>
           <a:p>
@@ -3381,8 +3468,38 @@
               </a:defRPr>
             </a:pPr>
             <a:r>
-              <a:t>1. Vũ Đình Đạo (Nhóm trưởng)                       2. Ngô Gia Bảo</a:t>
-            </a:r>
+              <a:rPr dirty="0"/>
+              <a:t>1. Vũ </a:t>
+            </a:r>
+            <a:r>
+              <a:rPr dirty="0" err="1"/>
+              <a:t>Đình</a:t>
+            </a:r>
+            <a:r>
+              <a:rPr dirty="0"/>
+              <a:t> </a:t>
+            </a:r>
+            <a:r>
+              <a:rPr dirty="0" err="1"/>
+              <a:t>Đạo</a:t>
+            </a:r>
+            <a:r>
+              <a:rPr dirty="0"/>
+              <a:t> </a:t>
+            </a:r>
+            <a:r>
+              <a:rPr lang="en-US" dirty="0"/>
+              <a:t>		</a:t>
+            </a:r>
+            <a:r>
+              <a:rPr dirty="0"/>
+              <a:t>                      2. Ngô Gia Bảo</a:t>
+            </a:r>
+            <a:r>
+              <a:rPr lang="vi-VN" dirty="0"/>
+              <a:t> (Nhóm trưởng) </a:t>
+            </a:r>
+            <a:endParaRPr dirty="0"/>
           </a:p>
           <a:p>
             <a:pPr>
@@ -3396,8 +3513,14 @@
               </a:defRPr>
             </a:pPr>
             <a:r>
-              <a:t>3. Nguyễn Tiến Dũng                                4. Lê Đức Trọng</a:t>
-            </a:r>
+              <a:rPr dirty="0"/>
+              <a:t>3. Nguyễn Tiến Dũng                                4. Lê Đức </a:t>
+            </a:r>
+            <a:r>
+              <a:rPr dirty="0" err="1"/>
+              <a:t>Trọng</a:t>
+            </a:r>
+            <a:endParaRPr dirty="0"/>
           </a:p>
           <a:p>
             <a:pPr>
@@ -3408,6 +3531,7 @@
               </a:defRPr>
             </a:pPr>
             <a:r>
+              <a:rPr dirty="0"/>
               <a:t>✦ Kotlin 2.0  ✦ Jetpack Compose M3  ✦ Room Database v3  ✦ MVVM + UDF  ✦ 100% Offline-First</a:t>
             </a:r>
           </a:p>
@@ -3422,7 +3546,7 @@
 </file>
 
 <file path=ppt/slides/slide10.xml><?xml version="1.0" encoding="utf-8"?>
-<p:sld xmlns:a="http://schemas.openxmlformats.org/drawingml/2006/main" xmlns:p="http://schemas.openxmlformats.org/presentationml/2006/main" xmlns:r="http://schemas.openxmlformats.org/officeDocument/2006/relationships">
+<p:sld xmlns:a="http://schemas.openxmlformats.org/drawingml/2006/main" xmlns:r="http://schemas.openxmlformats.org/officeDocument/2006/relationships" xmlns:p="http://schemas.openxmlformats.org/presentationml/2006/main">
   <p:cSld>
     <p:spTree>
       <p:nvGrpSpPr>
@@ -3430,7 +3554,14 @@
         <p:cNvGrpSpPr/>
         <p:nvPr/>
       </p:nvGrpSpPr>
-      <p:grpSpPr/>
+      <p:grpSpPr>
+        <a:xfrm>
+          <a:off x="0" y="0"/>
+          <a:ext cx="0" cy="0"/>
+          <a:chOff x="0" y="0"/>
+          <a:chExt cx="0" cy="0"/>
+        </a:xfrm>
+      </p:grpSpPr>
       <p:sp>
         <p:nvSpPr>
           <p:cNvPr id="2" name="Rectangle 1"/>
@@ -3471,6 +3602,7 @@
           <a:lstStyle/>
           <a:p>
             <a:pPr algn="ctr"/>
+            <a:endParaRPr/>
           </a:p>
         </p:txBody>
       </p:sp>
@@ -3619,6 +3751,7 @@
           <a:lstStyle/>
           <a:p>
             <a:pPr algn="ctr"/>
+            <a:endParaRPr/>
           </a:p>
         </p:txBody>
       </p:sp>
@@ -3699,6 +3832,7 @@
           <a:lstStyle/>
           <a:p>
             <a:pPr algn="ctr"/>
+            <a:endParaRPr/>
           </a:p>
         </p:txBody>
       </p:sp>
@@ -3725,7 +3859,7 @@
           <a:lstStyle/>
           <a:p>
             <a:pPr algn="ctr">
-              <a:defRPr b="1" sz="1050">
+              <a:defRPr sz="1050" b="1">
                 <a:solidFill>
                   <a:srgbClr val="1B4F72"/>
                 </a:solidFill>
@@ -3803,6 +3937,7 @@
           <a:lstStyle/>
           <a:p>
             <a:pPr algn="ctr"/>
+            <a:endParaRPr/>
           </a:p>
         </p:txBody>
       </p:sp>
@@ -3829,7 +3964,7 @@
           <a:lstStyle/>
           <a:p>
             <a:pPr algn="ctr">
-              <a:defRPr b="1" sz="1050">
+              <a:defRPr sz="1050" b="1">
                 <a:solidFill>
                   <a:srgbClr val="1B4F72"/>
                 </a:solidFill>
@@ -3907,6 +4042,7 @@
           <a:lstStyle/>
           <a:p>
             <a:pPr algn="ctr"/>
+            <a:endParaRPr/>
           </a:p>
         </p:txBody>
       </p:sp>
@@ -3951,7 +4087,7 @@
               <a:spcAft>
                 <a:spcPts val="600"/>
               </a:spcAft>
-              <a:defRPr b="1" sz="1350">
+              <a:defRPr sz="1350" b="1">
                 <a:solidFill>
                   <a:srgbClr val="1B4F72"/>
                 </a:solidFill>
@@ -4065,6 +4201,7 @@
           <a:lstStyle/>
           <a:p>
             <a:pPr algn="ctr"/>
+            <a:endParaRPr/>
           </a:p>
         </p:txBody>
       </p:sp>
@@ -4109,7 +4246,7 @@
               <a:spcAft>
                 <a:spcPts val="600"/>
               </a:spcAft>
-              <a:defRPr b="1" sz="1350">
+              <a:defRPr sz="1350" b="1">
                 <a:solidFill>
                   <a:srgbClr val="0E6655"/>
                 </a:solidFill>
@@ -4190,7 +4327,7 @@
 </file>
 
 <file path=ppt/slides/slide11.xml><?xml version="1.0" encoding="utf-8"?>
-<p:sld xmlns:a="http://schemas.openxmlformats.org/drawingml/2006/main" xmlns:p="http://schemas.openxmlformats.org/presentationml/2006/main" xmlns:r="http://schemas.openxmlformats.org/officeDocument/2006/relationships">
+<p:sld xmlns:a="http://schemas.openxmlformats.org/drawingml/2006/main" xmlns:r="http://schemas.openxmlformats.org/officeDocument/2006/relationships" xmlns:p="http://schemas.openxmlformats.org/presentationml/2006/main">
   <p:cSld>
     <p:spTree>
       <p:nvGrpSpPr>
@@ -4198,7 +4335,14 @@
         <p:cNvGrpSpPr/>
         <p:nvPr/>
       </p:nvGrpSpPr>
-      <p:grpSpPr/>
+      <p:grpSpPr>
+        <a:xfrm>
+          <a:off x="0" y="0"/>
+          <a:ext cx="0" cy="0"/>
+          <a:chOff x="0" y="0"/>
+          <a:chExt cx="0" cy="0"/>
+        </a:xfrm>
+      </p:grpSpPr>
       <p:sp>
         <p:nvSpPr>
           <p:cNvPr id="2" name="Rectangle 1"/>
@@ -4239,6 +4383,7 @@
           <a:lstStyle/>
           <a:p>
             <a:pPr algn="ctr"/>
+            <a:endParaRPr/>
           </a:p>
         </p:txBody>
       </p:sp>
@@ -4387,6 +4532,7 @@
           <a:lstStyle/>
           <a:p>
             <a:pPr algn="ctr"/>
+            <a:endParaRPr/>
           </a:p>
         </p:txBody>
       </p:sp>
@@ -4467,6 +4613,7 @@
           <a:lstStyle/>
           <a:p>
             <a:pPr algn="ctr"/>
+            <a:endParaRPr/>
           </a:p>
         </p:txBody>
       </p:sp>
@@ -4493,7 +4640,7 @@
           <a:lstStyle/>
           <a:p>
             <a:pPr algn="ctr">
-              <a:defRPr b="1" sz="1050">
+              <a:defRPr sz="1050" b="1">
                 <a:solidFill>
                   <a:srgbClr val="1B4F72"/>
                 </a:solidFill>
@@ -4571,6 +4718,7 @@
           <a:lstStyle/>
           <a:p>
             <a:pPr algn="ctr"/>
+            <a:endParaRPr/>
           </a:p>
         </p:txBody>
       </p:sp>
@@ -4597,7 +4745,7 @@
           <a:lstStyle/>
           <a:p>
             <a:pPr algn="ctr">
-              <a:defRPr b="1" sz="1050">
+              <a:defRPr sz="1050" b="1">
                 <a:solidFill>
                   <a:srgbClr val="1B4F72"/>
                 </a:solidFill>
@@ -4675,6 +4823,7 @@
           <a:lstStyle/>
           <a:p>
             <a:pPr algn="ctr"/>
+            <a:endParaRPr/>
           </a:p>
         </p:txBody>
       </p:sp>
@@ -4719,7 +4868,7 @@
               <a:spcAft>
                 <a:spcPts val="600"/>
               </a:spcAft>
-              <a:defRPr b="1" sz="1350">
+              <a:defRPr sz="1350" b="1">
                 <a:solidFill>
                   <a:srgbClr val="1B4F72"/>
                 </a:solidFill>
@@ -4833,6 +4982,7 @@
           <a:lstStyle/>
           <a:p>
             <a:pPr algn="ctr"/>
+            <a:endParaRPr/>
           </a:p>
         </p:txBody>
       </p:sp>
@@ -4877,7 +5027,7 @@
               <a:spcAft>
                 <a:spcPts val="600"/>
               </a:spcAft>
-              <a:defRPr b="1" sz="1350">
+              <a:defRPr sz="1350" b="1">
                 <a:solidFill>
                   <a:srgbClr val="0E6655"/>
                 </a:solidFill>
@@ -4958,7 +5108,7 @@
 </file>
 
 <file path=ppt/slides/slide12.xml><?xml version="1.0" encoding="utf-8"?>
-<p:sld xmlns:a="http://schemas.openxmlformats.org/drawingml/2006/main" xmlns:p="http://schemas.openxmlformats.org/presentationml/2006/main" xmlns:r="http://schemas.openxmlformats.org/officeDocument/2006/relationships">
+<p:sld xmlns:a="http://schemas.openxmlformats.org/drawingml/2006/main" xmlns:r="http://schemas.openxmlformats.org/officeDocument/2006/relationships" xmlns:p="http://schemas.openxmlformats.org/presentationml/2006/main">
   <p:cSld>
     <p:spTree>
       <p:nvGrpSpPr>
@@ -4966,7 +5116,14 @@
         <p:cNvGrpSpPr/>
         <p:nvPr/>
       </p:nvGrpSpPr>
-      <p:grpSpPr/>
+      <p:grpSpPr>
+        <a:xfrm>
+          <a:off x="0" y="0"/>
+          <a:ext cx="0" cy="0"/>
+          <a:chOff x="0" y="0"/>
+          <a:chExt cx="0" cy="0"/>
+        </a:xfrm>
+      </p:grpSpPr>
       <p:sp>
         <p:nvSpPr>
           <p:cNvPr id="2" name="Rectangle 1"/>
@@ -5007,6 +5164,7 @@
           <a:lstStyle/>
           <a:p>
             <a:pPr algn="ctr"/>
+            <a:endParaRPr/>
           </a:p>
         </p:txBody>
       </p:sp>
@@ -5155,6 +5313,7 @@
           <a:lstStyle/>
           <a:p>
             <a:pPr algn="ctr"/>
+            <a:endParaRPr/>
           </a:p>
         </p:txBody>
       </p:sp>
@@ -5235,6 +5394,7 @@
           <a:lstStyle/>
           <a:p>
             <a:pPr algn="ctr"/>
+            <a:endParaRPr/>
           </a:p>
         </p:txBody>
       </p:sp>
@@ -5261,7 +5421,7 @@
           <a:lstStyle/>
           <a:p>
             <a:pPr algn="ctr">
-              <a:defRPr b="1" sz="1050">
+              <a:defRPr sz="1050" b="1">
                 <a:solidFill>
                   <a:srgbClr val="1B4F72"/>
                 </a:solidFill>
@@ -5339,6 +5499,7 @@
           <a:lstStyle/>
           <a:p>
             <a:pPr algn="ctr"/>
+            <a:endParaRPr/>
           </a:p>
         </p:txBody>
       </p:sp>
@@ -5365,7 +5526,7 @@
           <a:lstStyle/>
           <a:p>
             <a:pPr algn="ctr">
-              <a:defRPr b="1" sz="1050">
+              <a:defRPr sz="1050" b="1">
                 <a:solidFill>
                   <a:srgbClr val="1B4F72"/>
                 </a:solidFill>
@@ -5443,6 +5604,7 @@
           <a:lstStyle/>
           <a:p>
             <a:pPr algn="ctr"/>
+            <a:endParaRPr/>
           </a:p>
         </p:txBody>
       </p:sp>
@@ -5487,7 +5649,7 @@
               <a:spcAft>
                 <a:spcPts val="600"/>
               </a:spcAft>
-              <a:defRPr b="1" sz="1350">
+              <a:defRPr sz="1350" b="1">
                 <a:solidFill>
                   <a:srgbClr val="1B4F72"/>
                 </a:solidFill>
@@ -5601,6 +5763,7 @@
           <a:lstStyle/>
           <a:p>
             <a:pPr algn="ctr"/>
+            <a:endParaRPr/>
           </a:p>
         </p:txBody>
       </p:sp>
@@ -5645,7 +5808,7 @@
               <a:spcAft>
                 <a:spcPts val="600"/>
               </a:spcAft>
-              <a:defRPr b="1" sz="1350">
+              <a:defRPr sz="1350" b="1">
                 <a:solidFill>
                   <a:srgbClr val="0E6655"/>
                 </a:solidFill>
@@ -5726,7 +5889,7 @@
 </file>
 
 <file path=ppt/slides/slide13.xml><?xml version="1.0" encoding="utf-8"?>
-<p:sld xmlns:a="http://schemas.openxmlformats.org/drawingml/2006/main" xmlns:p="http://schemas.openxmlformats.org/presentationml/2006/main" xmlns:r="http://schemas.openxmlformats.org/officeDocument/2006/relationships">
+<p:sld xmlns:a="http://schemas.openxmlformats.org/drawingml/2006/main" xmlns:r="http://schemas.openxmlformats.org/officeDocument/2006/relationships" xmlns:p="http://schemas.openxmlformats.org/presentationml/2006/main">
   <p:cSld>
     <p:spTree>
       <p:nvGrpSpPr>
@@ -5734,7 +5897,14 @@
         <p:cNvGrpSpPr/>
         <p:nvPr/>
       </p:nvGrpSpPr>
-      <p:grpSpPr/>
+      <p:grpSpPr>
+        <a:xfrm>
+          <a:off x="0" y="0"/>
+          <a:ext cx="0" cy="0"/>
+          <a:chOff x="0" y="0"/>
+          <a:chExt cx="0" cy="0"/>
+        </a:xfrm>
+      </p:grpSpPr>
       <p:sp>
         <p:nvSpPr>
           <p:cNvPr id="2" name="Rectangle 1"/>
@@ -5775,6 +5945,7 @@
           <a:lstStyle/>
           <a:p>
             <a:pPr algn="ctr"/>
+            <a:endParaRPr/>
           </a:p>
         </p:txBody>
       </p:sp>
@@ -5923,6 +6094,7 @@
           <a:lstStyle/>
           <a:p>
             <a:pPr algn="ctr"/>
+            <a:endParaRPr/>
           </a:p>
         </p:txBody>
       </p:sp>
@@ -6003,6 +6175,7 @@
           <a:lstStyle/>
           <a:p>
             <a:pPr algn="ctr"/>
+            <a:endParaRPr/>
           </a:p>
         </p:txBody>
       </p:sp>
@@ -6029,7 +6202,7 @@
           <a:lstStyle/>
           <a:p>
             <a:pPr algn="ctr">
-              <a:defRPr b="1" sz="2400">
+              <a:defRPr sz="2400" b="1">
                 <a:solidFill>
                   <a:srgbClr val="E65100"/>
                 </a:solidFill>
@@ -6044,7 +6217,7 @@
               <a:spcBef>
                 <a:spcPts val="200"/>
               </a:spcBef>
-              <a:defRPr b="1" sz="1100">
+              <a:defRPr sz="1100" b="1">
                 <a:solidFill>
                   <a:srgbClr val="1B4F72"/>
                 </a:solidFill>
@@ -6113,6 +6286,7 @@
           <a:lstStyle/>
           <a:p>
             <a:pPr algn="ctr"/>
+            <a:endParaRPr/>
           </a:p>
         </p:txBody>
       </p:sp>
@@ -6139,7 +6313,7 @@
           <a:lstStyle/>
           <a:p>
             <a:pPr algn="ctr">
-              <a:defRPr b="1" sz="2400">
+              <a:defRPr sz="2400" b="1">
                 <a:solidFill>
                   <a:srgbClr val="E65100"/>
                 </a:solidFill>
@@ -6154,7 +6328,7 @@
               <a:spcBef>
                 <a:spcPts val="200"/>
               </a:spcBef>
-              <a:defRPr b="1" sz="1100">
+              <a:defRPr sz="1100" b="1">
                 <a:solidFill>
                   <a:srgbClr val="1B4F72"/>
                 </a:solidFill>
@@ -6223,6 +6397,7 @@
           <a:lstStyle/>
           <a:p>
             <a:pPr algn="ctr"/>
+            <a:endParaRPr/>
           </a:p>
         </p:txBody>
       </p:sp>
@@ -6249,7 +6424,7 @@
           <a:lstStyle/>
           <a:p>
             <a:pPr algn="ctr">
-              <a:defRPr b="1" sz="2400">
+              <a:defRPr sz="2400" b="1">
                 <a:solidFill>
                   <a:srgbClr val="E65100"/>
                 </a:solidFill>
@@ -6264,7 +6439,7 @@
               <a:spcBef>
                 <a:spcPts val="200"/>
               </a:spcBef>
-              <a:defRPr b="1" sz="1100">
+              <a:defRPr sz="1100" b="1">
                 <a:solidFill>
                   <a:srgbClr val="1B4F72"/>
                 </a:solidFill>
@@ -6333,6 +6508,7 @@
           <a:lstStyle/>
           <a:p>
             <a:pPr algn="ctr"/>
+            <a:endParaRPr/>
           </a:p>
         </p:txBody>
       </p:sp>
@@ -6359,7 +6535,7 @@
           <a:lstStyle/>
           <a:p>
             <a:pPr algn="ctr">
-              <a:defRPr b="1" sz="2400">
+              <a:defRPr sz="2400" b="1">
                 <a:solidFill>
                   <a:srgbClr val="E65100"/>
                 </a:solidFill>
@@ -6374,7 +6550,7 @@
               <a:spcBef>
                 <a:spcPts val="200"/>
               </a:spcBef>
-              <a:defRPr b="1" sz="1100">
+              <a:defRPr sz="1100" b="1">
                 <a:solidFill>
                   <a:srgbClr val="1B4F72"/>
                 </a:solidFill>
@@ -6443,6 +6619,7 @@
           <a:lstStyle/>
           <a:p>
             <a:pPr algn="ctr"/>
+            <a:endParaRPr/>
           </a:p>
         </p:txBody>
       </p:sp>
@@ -6487,7 +6664,7 @@
               <a:spcAft>
                 <a:spcPts val="600"/>
               </a:spcAft>
-              <a:defRPr b="1" sz="1350">
+              <a:defRPr sz="1350" b="1">
                 <a:solidFill>
                   <a:srgbClr val="1B4F72"/>
                 </a:solidFill>
@@ -6601,6 +6778,7 @@
           <a:lstStyle/>
           <a:p>
             <a:pPr algn="ctr"/>
+            <a:endParaRPr/>
           </a:p>
         </p:txBody>
       </p:sp>
@@ -6645,7 +6823,7 @@
               <a:spcAft>
                 <a:spcPts val="600"/>
               </a:spcAft>
-              <a:defRPr b="1" sz="1350">
+              <a:defRPr sz="1350" b="1">
                 <a:solidFill>
                   <a:srgbClr val="0E6655"/>
                 </a:solidFill>
@@ -6726,7 +6904,7 @@
 </file>
 
 <file path=ppt/slides/slide14.xml><?xml version="1.0" encoding="utf-8"?>
-<p:sld xmlns:a="http://schemas.openxmlformats.org/drawingml/2006/main" xmlns:p="http://schemas.openxmlformats.org/presentationml/2006/main" xmlns:r="http://schemas.openxmlformats.org/officeDocument/2006/relationships">
+<p:sld xmlns:a="http://schemas.openxmlformats.org/drawingml/2006/main" xmlns:r="http://schemas.openxmlformats.org/officeDocument/2006/relationships" xmlns:p="http://schemas.openxmlformats.org/presentationml/2006/main">
   <p:cSld>
     <p:spTree>
       <p:nvGrpSpPr>
@@ -6734,7 +6912,14 @@
         <p:cNvGrpSpPr/>
         <p:nvPr/>
       </p:nvGrpSpPr>
-      <p:grpSpPr/>
+      <p:grpSpPr>
+        <a:xfrm>
+          <a:off x="0" y="0"/>
+          <a:ext cx="0" cy="0"/>
+          <a:chOff x="0" y="0"/>
+          <a:chExt cx="0" cy="0"/>
+        </a:xfrm>
+      </p:grpSpPr>
       <p:sp>
         <p:nvSpPr>
           <p:cNvPr id="2" name="Rectangle 1"/>
@@ -6775,6 +6960,7 @@
           <a:lstStyle/>
           <a:p>
             <a:pPr algn="ctr"/>
+            <a:endParaRPr/>
           </a:p>
         </p:txBody>
       </p:sp>
@@ -6923,6 +7109,7 @@
           <a:lstStyle/>
           <a:p>
             <a:pPr algn="ctr"/>
+            <a:endParaRPr/>
           </a:p>
         </p:txBody>
       </p:sp>
@@ -7003,6 +7190,7 @@
           <a:lstStyle/>
           <a:p>
             <a:pPr algn="ctr"/>
+            <a:endParaRPr/>
           </a:p>
         </p:txBody>
       </p:sp>
@@ -7047,7 +7235,7 @@
               <a:spcAft>
                 <a:spcPts val="600"/>
               </a:spcAft>
-              <a:defRPr b="1" sz="1350">
+              <a:defRPr sz="1350" b="1">
                 <a:solidFill>
                   <a:srgbClr val="0E6655"/>
                 </a:solidFill>
@@ -7176,6 +7364,7 @@
           <a:lstStyle/>
           <a:p>
             <a:pPr algn="ctr"/>
+            <a:endParaRPr/>
           </a:p>
         </p:txBody>
       </p:sp>
@@ -7220,7 +7409,7 @@
               <a:spcAft>
                 <a:spcPts val="600"/>
               </a:spcAft>
-              <a:defRPr b="1" sz="1350">
+              <a:defRPr sz="1350" b="1">
                 <a:solidFill>
                   <a:srgbClr val="E65100"/>
                 </a:solidFill>
@@ -7301,7 +7490,7 @@
 </file>
 
 <file path=ppt/slides/slide15.xml><?xml version="1.0" encoding="utf-8"?>
-<p:sld xmlns:a="http://schemas.openxmlformats.org/drawingml/2006/main" xmlns:p="http://schemas.openxmlformats.org/presentationml/2006/main" xmlns:r="http://schemas.openxmlformats.org/officeDocument/2006/relationships">
+<p:sld xmlns:a="http://schemas.openxmlformats.org/drawingml/2006/main" xmlns:r="http://schemas.openxmlformats.org/officeDocument/2006/relationships" xmlns:p="http://schemas.openxmlformats.org/presentationml/2006/main">
   <p:cSld>
     <p:spTree>
       <p:nvGrpSpPr>
@@ -7309,7 +7498,14 @@
         <p:cNvGrpSpPr/>
         <p:nvPr/>
       </p:nvGrpSpPr>
-      <p:grpSpPr/>
+      <p:grpSpPr>
+        <a:xfrm>
+          <a:off x="0" y="0"/>
+          <a:ext cx="0" cy="0"/>
+          <a:chOff x="0" y="0"/>
+          <a:chExt cx="0" cy="0"/>
+        </a:xfrm>
+      </p:grpSpPr>
       <p:sp>
         <p:nvSpPr>
           <p:cNvPr id="2" name="Rectangle 1"/>
@@ -7350,6 +7546,7 @@
           <a:lstStyle/>
           <a:p>
             <a:pPr algn="ctr"/>
+            <a:endParaRPr/>
           </a:p>
         </p:txBody>
       </p:sp>
@@ -7498,6 +7695,7 @@
           <a:lstStyle/>
           <a:p>
             <a:pPr algn="ctr"/>
+            <a:endParaRPr/>
           </a:p>
         </p:txBody>
       </p:sp>
@@ -7578,6 +7776,7 @@
           <a:lstStyle/>
           <a:p>
             <a:pPr algn="ctr"/>
+            <a:endParaRPr/>
           </a:p>
         </p:txBody>
       </p:sp>
@@ -7590,7 +7789,7 @@
         <p:spPr>
           <a:xfrm>
             <a:off x="960120" y="1645920"/>
-            <a:ext cx="2880360" cy="4389120"/>
+            <a:ext cx="2880360" cy="2090316"/>
           </a:xfrm>
           <a:prstGeom prst="rect">
             <a:avLst/>
@@ -7614,6 +7813,7 @@
               </a:defRPr>
             </a:pPr>
             <a:r>
+              <a:rPr dirty="0"/>
               <a:t>NGẮN HẠN: THỊ GIÁC MÁY TÍNH</a:t>
             </a:r>
           </a:p>
@@ -7622,14 +7822,15 @@
               <a:spcAft>
                 <a:spcPts val="600"/>
               </a:spcAft>
-              <a:defRPr b="1" sz="1350">
+              <a:defRPr sz="1350" b="1">
                 <a:solidFill>
                   <a:srgbClr val="1B4F72"/>
                 </a:solidFill>
               </a:defRPr>
             </a:pPr>
             <a:r>
-              <a:t>📸 AI Camera Vision (1-3 tháng)</a:t>
+              <a:rPr dirty="0"/>
+              <a:t>📸 AI Camera Vision</a:t>
             </a:r>
           </a:p>
           <a:p>
@@ -7644,7 +7845,224 @@
               </a:defRPr>
             </a:pPr>
             <a:r>
-              <a:t>•  Quét hóa đơn mua hàng siêu thị: Tự động trích xuất tên nguyên liệu và hạn dùng để nhập kho tủ lạnh Pantry chỉ với 1 bức ảnh chụp.</a:t>
+              <a:rPr dirty="0"/>
+              <a:t>•  </a:t>
+            </a:r>
+            <a:r>
+              <a:rPr dirty="0" err="1"/>
+              <a:t>Quét</a:t>
+            </a:r>
+            <a:r>
+              <a:rPr dirty="0"/>
+              <a:t> </a:t>
+            </a:r>
+            <a:r>
+              <a:rPr dirty="0" err="1"/>
+              <a:t>hóa</a:t>
+            </a:r>
+            <a:r>
+              <a:rPr dirty="0"/>
+              <a:t> </a:t>
+            </a:r>
+            <a:r>
+              <a:rPr dirty="0" err="1"/>
+              <a:t>đơn</a:t>
+            </a:r>
+            <a:r>
+              <a:rPr dirty="0"/>
+              <a:t> </a:t>
+            </a:r>
+            <a:r>
+              <a:rPr dirty="0" err="1"/>
+              <a:t>mua</a:t>
+            </a:r>
+            <a:r>
+              <a:rPr dirty="0"/>
+              <a:t> </a:t>
+            </a:r>
+            <a:r>
+              <a:rPr dirty="0" err="1"/>
+              <a:t>hàng</a:t>
+            </a:r>
+            <a:r>
+              <a:rPr dirty="0"/>
+              <a:t> </a:t>
+            </a:r>
+            <a:r>
+              <a:rPr dirty="0" err="1"/>
+              <a:t>siêu</a:t>
+            </a:r>
+            <a:r>
+              <a:rPr dirty="0"/>
+              <a:t> </a:t>
+            </a:r>
+            <a:r>
+              <a:rPr dirty="0" err="1"/>
+              <a:t>thị</a:t>
+            </a:r>
+            <a:r>
+              <a:rPr dirty="0"/>
+              <a:t>: </a:t>
+            </a:r>
+            <a:r>
+              <a:rPr dirty="0" err="1"/>
+              <a:t>Tự</a:t>
+            </a:r>
+            <a:r>
+              <a:rPr dirty="0"/>
+              <a:t> </a:t>
+            </a:r>
+            <a:r>
+              <a:rPr dirty="0" err="1"/>
+              <a:t>động</a:t>
+            </a:r>
+            <a:r>
+              <a:rPr dirty="0"/>
+              <a:t> </a:t>
+            </a:r>
+            <a:r>
+              <a:rPr dirty="0" err="1"/>
+              <a:t>trích</a:t>
+            </a:r>
+            <a:r>
+              <a:rPr dirty="0"/>
+              <a:t> </a:t>
+            </a:r>
+            <a:r>
+              <a:rPr dirty="0" err="1"/>
+              <a:t>xuất</a:t>
+            </a:r>
+            <a:r>
+              <a:rPr dirty="0"/>
+              <a:t> </a:t>
+            </a:r>
+            <a:r>
+              <a:rPr dirty="0" err="1"/>
+              <a:t>tên</a:t>
+            </a:r>
+            <a:r>
+              <a:rPr dirty="0"/>
+              <a:t> </a:t>
+            </a:r>
+            <a:r>
+              <a:rPr dirty="0" err="1"/>
+              <a:t>nguyên</a:t>
+            </a:r>
+            <a:r>
+              <a:rPr dirty="0"/>
+              <a:t> </a:t>
+            </a:r>
+            <a:r>
+              <a:rPr dirty="0" err="1"/>
+              <a:t>liệu</a:t>
+            </a:r>
+            <a:r>
+              <a:rPr dirty="0"/>
+              <a:t> </a:t>
+            </a:r>
+            <a:r>
+              <a:rPr dirty="0" err="1"/>
+              <a:t>và</a:t>
+            </a:r>
+            <a:r>
+              <a:rPr dirty="0"/>
+              <a:t> </a:t>
+            </a:r>
+            <a:r>
+              <a:rPr dirty="0" err="1"/>
+              <a:t>hạn</a:t>
+            </a:r>
+            <a:r>
+              <a:rPr dirty="0"/>
+              <a:t> </a:t>
+            </a:r>
+            <a:r>
+              <a:rPr dirty="0" err="1"/>
+              <a:t>dùng</a:t>
+            </a:r>
+            <a:r>
+              <a:rPr dirty="0"/>
+              <a:t> </a:t>
+            </a:r>
+            <a:r>
+              <a:rPr dirty="0" err="1"/>
+              <a:t>để</a:t>
+            </a:r>
+            <a:r>
+              <a:rPr dirty="0"/>
+              <a:t> </a:t>
+            </a:r>
+            <a:r>
+              <a:rPr dirty="0" err="1"/>
+              <a:t>nhập</a:t>
+            </a:r>
+            <a:r>
+              <a:rPr dirty="0"/>
+              <a:t> </a:t>
+            </a:r>
+            <a:r>
+              <a:rPr dirty="0" err="1"/>
+              <a:t>kho</a:t>
+            </a:r>
+            <a:r>
+              <a:rPr dirty="0"/>
+              <a:t> </a:t>
+            </a:r>
+            <a:r>
+              <a:rPr dirty="0" err="1"/>
+              <a:t>tủ</a:t>
+            </a:r>
+            <a:r>
+              <a:rPr dirty="0"/>
+              <a:t> </a:t>
+            </a:r>
+            <a:r>
+              <a:rPr dirty="0" err="1"/>
+              <a:t>lạnh</a:t>
+            </a:r>
+            <a:r>
+              <a:rPr dirty="0"/>
+              <a:t> Pantry </a:t>
+            </a:r>
+            <a:r>
+              <a:rPr dirty="0" err="1"/>
+              <a:t>chỉ</a:t>
+            </a:r>
+            <a:r>
+              <a:rPr dirty="0"/>
+              <a:t> </a:t>
+            </a:r>
+            <a:r>
+              <a:rPr dirty="0" err="1"/>
+              <a:t>với</a:t>
+            </a:r>
+            <a:r>
+              <a:rPr dirty="0"/>
+              <a:t> 1 </a:t>
+            </a:r>
+            <a:r>
+              <a:rPr dirty="0" err="1"/>
+              <a:t>bức</a:t>
+            </a:r>
+            <a:r>
+              <a:rPr dirty="0"/>
+              <a:t> </a:t>
+            </a:r>
+            <a:r>
+              <a:rPr dirty="0" err="1"/>
+              <a:t>ảnh</a:t>
+            </a:r>
+            <a:r>
+              <a:rPr dirty="0"/>
+              <a:t> </a:t>
+            </a:r>
+            <a:r>
+              <a:rPr dirty="0" err="1"/>
+              <a:t>chụp</a:t>
+            </a:r>
+            <a:r>
+              <a:rPr dirty="0"/>
+              <a:t>.</a:t>
             </a:r>
           </a:p>
           <a:p>
@@ -7659,7 +8077,200 @@
               </a:defRPr>
             </a:pPr>
             <a:r>
-              <a:t>•  Nhận diện thực phẩm qua Camera: Hướng camera vào rau củ quả trong tủ lạnh để AI tự động nhận diện và cập nhật danh mục tồn kho.</a:t>
+              <a:rPr dirty="0"/>
+              <a:t>•  </a:t>
+            </a:r>
+            <a:r>
+              <a:rPr dirty="0" err="1"/>
+              <a:t>Nhận</a:t>
+            </a:r>
+            <a:r>
+              <a:rPr dirty="0"/>
+              <a:t> </a:t>
+            </a:r>
+            <a:r>
+              <a:rPr dirty="0" err="1"/>
+              <a:t>diện</a:t>
+            </a:r>
+            <a:r>
+              <a:rPr dirty="0"/>
+              <a:t> </a:t>
+            </a:r>
+            <a:r>
+              <a:rPr dirty="0" err="1"/>
+              <a:t>thực</a:t>
+            </a:r>
+            <a:r>
+              <a:rPr dirty="0"/>
+              <a:t> </a:t>
+            </a:r>
+            <a:r>
+              <a:rPr dirty="0" err="1"/>
+              <a:t>phẩm</a:t>
+            </a:r>
+            <a:r>
+              <a:rPr dirty="0"/>
+              <a:t> qua Camera: </a:t>
+            </a:r>
+            <a:r>
+              <a:rPr dirty="0" err="1"/>
+              <a:t>Hướng</a:t>
+            </a:r>
+            <a:r>
+              <a:rPr dirty="0"/>
+              <a:t> camera </a:t>
+            </a:r>
+            <a:r>
+              <a:rPr dirty="0" err="1"/>
+              <a:t>vào</a:t>
+            </a:r>
+            <a:r>
+              <a:rPr dirty="0"/>
+              <a:t> </a:t>
+            </a:r>
+            <a:r>
+              <a:rPr dirty="0" err="1"/>
+              <a:t>rau</a:t>
+            </a:r>
+            <a:r>
+              <a:rPr dirty="0"/>
+              <a:t> </a:t>
+            </a:r>
+            <a:r>
+              <a:rPr dirty="0" err="1"/>
+              <a:t>củ</a:t>
+            </a:r>
+            <a:r>
+              <a:rPr dirty="0"/>
+              <a:t> </a:t>
+            </a:r>
+            <a:r>
+              <a:rPr dirty="0" err="1"/>
+              <a:t>quả</a:t>
+            </a:r>
+            <a:r>
+              <a:rPr dirty="0"/>
+              <a:t> </a:t>
+            </a:r>
+            <a:r>
+              <a:rPr dirty="0" err="1"/>
+              <a:t>trong</a:t>
+            </a:r>
+            <a:r>
+              <a:rPr dirty="0"/>
+              <a:t> </a:t>
+            </a:r>
+            <a:r>
+              <a:rPr dirty="0" err="1"/>
+              <a:t>tủ</a:t>
+            </a:r>
+            <a:r>
+              <a:rPr dirty="0"/>
+              <a:t> </a:t>
+            </a:r>
+            <a:r>
+              <a:rPr dirty="0" err="1"/>
+              <a:t>lạnh</a:t>
+            </a:r>
+            <a:r>
+              <a:rPr dirty="0"/>
+              <a:t> </a:t>
+            </a:r>
+            <a:r>
+              <a:rPr dirty="0" err="1"/>
+              <a:t>để</a:t>
+            </a:r>
+            <a:r>
+              <a:rPr dirty="0"/>
+              <a:t> AI </a:t>
+            </a:r>
+            <a:r>
+              <a:rPr dirty="0" err="1"/>
+              <a:t>tự</a:t>
+            </a:r>
+            <a:r>
+              <a:rPr dirty="0"/>
+              <a:t> </a:t>
+            </a:r>
+            <a:r>
+              <a:rPr dirty="0" err="1"/>
+              <a:t>động</a:t>
+            </a:r>
+            <a:r>
+              <a:rPr dirty="0"/>
+              <a:t> </a:t>
+            </a:r>
+            <a:r>
+              <a:rPr dirty="0" err="1"/>
+              <a:t>nhận</a:t>
+            </a:r>
+            <a:r>
+              <a:rPr dirty="0"/>
+              <a:t> </a:t>
+            </a:r>
+            <a:r>
+              <a:rPr dirty="0" err="1"/>
+              <a:t>diện</a:t>
+            </a:r>
+            <a:r>
+              <a:rPr dirty="0"/>
+              <a:t> </a:t>
+            </a:r>
+            <a:r>
+              <a:rPr dirty="0" err="1"/>
+              <a:t>và</a:t>
+            </a:r>
+            <a:r>
+              <a:rPr dirty="0"/>
+              <a:t> </a:t>
+            </a:r>
+            <a:r>
+              <a:rPr dirty="0" err="1"/>
+              <a:t>cập</a:t>
+            </a:r>
+            <a:r>
+              <a:rPr dirty="0"/>
+              <a:t> </a:t>
+            </a:r>
+            <a:r>
+              <a:rPr dirty="0" err="1"/>
+              <a:t>nhật</a:t>
+            </a:r>
+            <a:r>
+              <a:rPr dirty="0"/>
+              <a:t> </a:t>
+            </a:r>
+            <a:r>
+              <a:rPr dirty="0" err="1"/>
+              <a:t>danh</a:t>
+            </a:r>
+            <a:r>
+              <a:rPr dirty="0"/>
+              <a:t> </a:t>
+            </a:r>
+            <a:r>
+              <a:rPr dirty="0" err="1"/>
+              <a:t>mục</a:t>
+            </a:r>
+            <a:r>
+              <a:rPr dirty="0"/>
+              <a:t> </a:t>
+            </a:r>
+            <a:r>
+              <a:rPr dirty="0" err="1"/>
+              <a:t>tồn</a:t>
+            </a:r>
+            <a:r>
+              <a:rPr dirty="0"/>
+              <a:t> </a:t>
+            </a:r>
+            <a:r>
+              <a:rPr dirty="0" err="1"/>
+              <a:t>kho</a:t>
+            </a:r>
+            <a:r>
+              <a:rPr dirty="0"/>
+              <a:t>.</a:t>
             </a:r>
           </a:p>
           <a:p>
@@ -7674,7 +8285,208 @@
               </a:defRPr>
             </a:pPr>
             <a:r>
-              <a:t>•  Chụp ảnh món ăn hoàn thiện: AI đánh giá màu sắc, độ chín và tự động chấm điểm trang trí món ăn cho người nội trợ.</a:t>
+              <a:rPr dirty="0"/>
+              <a:t>•  </a:t>
+            </a:r>
+            <a:r>
+              <a:rPr dirty="0" err="1"/>
+              <a:t>Chụp</a:t>
+            </a:r>
+            <a:r>
+              <a:rPr dirty="0"/>
+              <a:t> </a:t>
+            </a:r>
+            <a:r>
+              <a:rPr dirty="0" err="1"/>
+              <a:t>ảnh</a:t>
+            </a:r>
+            <a:r>
+              <a:rPr dirty="0"/>
+              <a:t> </a:t>
+            </a:r>
+            <a:r>
+              <a:rPr dirty="0" err="1"/>
+              <a:t>món</a:t>
+            </a:r>
+            <a:r>
+              <a:rPr dirty="0"/>
+              <a:t> </a:t>
+            </a:r>
+            <a:r>
+              <a:rPr dirty="0" err="1"/>
+              <a:t>ăn</a:t>
+            </a:r>
+            <a:r>
+              <a:rPr dirty="0"/>
+              <a:t> </a:t>
+            </a:r>
+            <a:r>
+              <a:rPr dirty="0" err="1"/>
+              <a:t>hoàn</a:t>
+            </a:r>
+            <a:r>
+              <a:rPr dirty="0"/>
+              <a:t> </a:t>
+            </a:r>
+            <a:r>
+              <a:rPr dirty="0" err="1"/>
+              <a:t>thiện</a:t>
+            </a:r>
+            <a:r>
+              <a:rPr dirty="0"/>
+              <a:t>: AI </a:t>
+            </a:r>
+            <a:r>
+              <a:rPr dirty="0" err="1"/>
+              <a:t>đánh</a:t>
+            </a:r>
+            <a:r>
+              <a:rPr dirty="0"/>
+              <a:t> </a:t>
+            </a:r>
+            <a:r>
+              <a:rPr dirty="0" err="1"/>
+              <a:t>giá</a:t>
+            </a:r>
+            <a:r>
+              <a:rPr dirty="0"/>
+              <a:t> </a:t>
+            </a:r>
+            <a:r>
+              <a:rPr dirty="0" err="1"/>
+              <a:t>màu</a:t>
+            </a:r>
+            <a:r>
+              <a:rPr dirty="0"/>
+              <a:t> </a:t>
+            </a:r>
+            <a:r>
+              <a:rPr dirty="0" err="1"/>
+              <a:t>sắc</a:t>
+            </a:r>
+            <a:r>
+              <a:rPr dirty="0"/>
+              <a:t>, </a:t>
+            </a:r>
+            <a:r>
+              <a:rPr dirty="0" err="1"/>
+              <a:t>độ</a:t>
+            </a:r>
+            <a:r>
+              <a:rPr dirty="0"/>
+              <a:t> </a:t>
+            </a:r>
+            <a:r>
+              <a:rPr dirty="0" err="1"/>
+              <a:t>chín</a:t>
+            </a:r>
+            <a:r>
+              <a:rPr dirty="0"/>
+              <a:t> </a:t>
+            </a:r>
+            <a:r>
+              <a:rPr dirty="0" err="1"/>
+              <a:t>và</a:t>
+            </a:r>
+            <a:r>
+              <a:rPr dirty="0"/>
+              <a:t> </a:t>
+            </a:r>
+            <a:r>
+              <a:rPr dirty="0" err="1"/>
+              <a:t>tự</a:t>
+            </a:r>
+            <a:r>
+              <a:rPr dirty="0"/>
+              <a:t> </a:t>
+            </a:r>
+            <a:r>
+              <a:rPr dirty="0" err="1"/>
+              <a:t>động</a:t>
+            </a:r>
+            <a:r>
+              <a:rPr dirty="0"/>
+              <a:t> </a:t>
+            </a:r>
+            <a:r>
+              <a:rPr dirty="0" err="1"/>
+              <a:t>chấm</a:t>
+            </a:r>
+            <a:r>
+              <a:rPr dirty="0"/>
+              <a:t> </a:t>
+            </a:r>
+            <a:r>
+              <a:rPr dirty="0" err="1"/>
+              <a:t>điểm</a:t>
+            </a:r>
+            <a:r>
+              <a:rPr dirty="0"/>
+              <a:t> </a:t>
+            </a:r>
+            <a:r>
+              <a:rPr dirty="0" err="1"/>
+              <a:t>trang</a:t>
+            </a:r>
+            <a:r>
+              <a:rPr dirty="0"/>
+              <a:t> </a:t>
+            </a:r>
+            <a:r>
+              <a:rPr dirty="0" err="1"/>
+              <a:t>trí</a:t>
+            </a:r>
+            <a:r>
+              <a:rPr dirty="0"/>
+              <a:t> </a:t>
+            </a:r>
+            <a:r>
+              <a:rPr dirty="0" err="1"/>
+              <a:t>món</a:t>
+            </a:r>
+            <a:r>
+              <a:rPr dirty="0"/>
+              <a:t> </a:t>
+            </a:r>
+            <a:r>
+              <a:rPr dirty="0" err="1"/>
+              <a:t>ăn</a:t>
+            </a:r>
+            <a:r>
+              <a:rPr dirty="0"/>
+              <a:t> </a:t>
+            </a:r>
+            <a:r>
+              <a:rPr dirty="0" err="1"/>
+              <a:t>cho</a:t>
+            </a:r>
+            <a:r>
+              <a:rPr dirty="0"/>
+              <a:t> </a:t>
+            </a:r>
+            <a:r>
+              <a:rPr dirty="0" err="1"/>
+              <a:t>người</a:t>
+            </a:r>
+            <a:r>
+              <a:rPr dirty="0"/>
+              <a:t> </a:t>
+            </a:r>
+            <a:r>
+              <a:rPr dirty="0" err="1"/>
+              <a:t>nội</a:t>
+            </a:r>
+            <a:r>
+              <a:rPr dirty="0"/>
+              <a:t> </a:t>
+            </a:r>
+            <a:r>
+              <a:rPr dirty="0" err="1"/>
+              <a:t>trợ</a:t>
+            </a:r>
+            <a:r>
+              <a:rPr dirty="0"/>
+              <a:t>.</a:t>
             </a:r>
           </a:p>
         </p:txBody>
@@ -7721,6 +8533,7 @@
           <a:lstStyle/>
           <a:p>
             <a:pPr algn="ctr"/>
+            <a:endParaRPr/>
           </a:p>
         </p:txBody>
       </p:sp>
@@ -7733,7 +8546,7 @@
         <p:spPr>
           <a:xfrm>
             <a:off x="4654296" y="1645920"/>
-            <a:ext cx="2880360" cy="4389120"/>
+            <a:ext cx="2880360" cy="2259593"/>
           </a:xfrm>
           <a:prstGeom prst="rect">
             <a:avLst/>
@@ -7757,6 +8570,7 @@
               </a:defRPr>
             </a:pPr>
             <a:r>
+              <a:rPr dirty="0"/>
               <a:t>TRUNG HẠN: TƯƠNG TÁC TỰ NHIÊN</a:t>
             </a:r>
           </a:p>
@@ -7765,15 +8579,45 @@
               <a:spcAft>
                 <a:spcPts val="600"/>
               </a:spcAft>
-              <a:defRPr b="1" sz="1350">
+              <a:defRPr sz="1350" b="1">
                 <a:solidFill>
                   <a:srgbClr val="0E6655"/>
                 </a:solidFill>
               </a:defRPr>
             </a:pPr>
             <a:r>
-              <a:t>🎙️ Trợ lý Rảnh tay (3-6 tháng)</a:t>
-            </a:r>
+              <a:rPr dirty="0"/>
+              <a:t>🎙️ </a:t>
+            </a:r>
+            <a:r>
+              <a:rPr dirty="0" err="1"/>
+              <a:t>Trợ</a:t>
+            </a:r>
+            <a:r>
+              <a:rPr dirty="0"/>
+              <a:t> </a:t>
+            </a:r>
+            <a:r>
+              <a:rPr dirty="0" err="1"/>
+              <a:t>lý</a:t>
+            </a:r>
+            <a:r>
+              <a:rPr dirty="0"/>
+              <a:t> </a:t>
+            </a:r>
+            <a:r>
+              <a:rPr dirty="0" err="1"/>
+              <a:t>Rảnh</a:t>
+            </a:r>
+            <a:r>
+              <a:rPr dirty="0"/>
+              <a:t> </a:t>
+            </a:r>
+            <a:r>
+              <a:rPr lang="en-US" dirty="0" err="1"/>
+              <a:t>tay</a:t>
+            </a:r>
+            <a:endParaRPr dirty="0"/>
           </a:p>
           <a:p>
             <a:pPr>
@@ -7787,7 +8631,216 @@
               </a:defRPr>
             </a:pPr>
             <a:r>
-              <a:t>•  Điều khiển bằng giọng nói (Voice Command): Đọc bước tiếp theo, tạm dừng hoặc hẹn giờ nấu nướng mà không cần chạm tay ướt/bẩn vào màn hình.</a:t>
+              <a:rPr dirty="0"/>
+              <a:t>•  </a:t>
+            </a:r>
+            <a:r>
+              <a:rPr dirty="0" err="1"/>
+              <a:t>Điều</a:t>
+            </a:r>
+            <a:r>
+              <a:rPr dirty="0"/>
+              <a:t> </a:t>
+            </a:r>
+            <a:r>
+              <a:rPr dirty="0" err="1"/>
+              <a:t>khiển</a:t>
+            </a:r>
+            <a:r>
+              <a:rPr dirty="0"/>
+              <a:t> </a:t>
+            </a:r>
+            <a:r>
+              <a:rPr dirty="0" err="1"/>
+              <a:t>bằng</a:t>
+            </a:r>
+            <a:r>
+              <a:rPr dirty="0"/>
+              <a:t> </a:t>
+            </a:r>
+            <a:r>
+              <a:rPr dirty="0" err="1"/>
+              <a:t>giọng</a:t>
+            </a:r>
+            <a:r>
+              <a:rPr dirty="0"/>
+              <a:t> </a:t>
+            </a:r>
+            <a:r>
+              <a:rPr dirty="0" err="1"/>
+              <a:t>nói</a:t>
+            </a:r>
+            <a:r>
+              <a:rPr dirty="0"/>
+              <a:t> (Voice Command): </a:t>
+            </a:r>
+            <a:r>
+              <a:rPr dirty="0" err="1"/>
+              <a:t>Đọc</a:t>
+            </a:r>
+            <a:r>
+              <a:rPr dirty="0"/>
+              <a:t> </a:t>
+            </a:r>
+            <a:r>
+              <a:rPr dirty="0" err="1"/>
+              <a:t>bước</a:t>
+            </a:r>
+            <a:r>
+              <a:rPr dirty="0"/>
+              <a:t> </a:t>
+            </a:r>
+            <a:r>
+              <a:rPr dirty="0" err="1"/>
+              <a:t>tiếp</a:t>
+            </a:r>
+            <a:r>
+              <a:rPr dirty="0"/>
+              <a:t> </a:t>
+            </a:r>
+            <a:r>
+              <a:rPr dirty="0" err="1"/>
+              <a:t>theo</a:t>
+            </a:r>
+            <a:r>
+              <a:rPr dirty="0"/>
+              <a:t>, </a:t>
+            </a:r>
+            <a:r>
+              <a:rPr dirty="0" err="1"/>
+              <a:t>tạm</a:t>
+            </a:r>
+            <a:r>
+              <a:rPr dirty="0"/>
+              <a:t> </a:t>
+            </a:r>
+            <a:r>
+              <a:rPr dirty="0" err="1"/>
+              <a:t>dừng</a:t>
+            </a:r>
+            <a:r>
+              <a:rPr dirty="0"/>
+              <a:t> </a:t>
+            </a:r>
+            <a:r>
+              <a:rPr dirty="0" err="1"/>
+              <a:t>hoặc</a:t>
+            </a:r>
+            <a:r>
+              <a:rPr dirty="0"/>
+              <a:t> </a:t>
+            </a:r>
+            <a:r>
+              <a:rPr dirty="0" err="1"/>
+              <a:t>hẹn</a:t>
+            </a:r>
+            <a:r>
+              <a:rPr dirty="0"/>
+              <a:t> </a:t>
+            </a:r>
+            <a:r>
+              <a:rPr dirty="0" err="1"/>
+              <a:t>giờ</a:t>
+            </a:r>
+            <a:r>
+              <a:rPr dirty="0"/>
+              <a:t> </a:t>
+            </a:r>
+            <a:r>
+              <a:rPr dirty="0" err="1"/>
+              <a:t>nấu</a:t>
+            </a:r>
+            <a:r>
+              <a:rPr dirty="0"/>
+              <a:t> </a:t>
+            </a:r>
+            <a:r>
+              <a:rPr dirty="0" err="1"/>
+              <a:t>nướng</a:t>
+            </a:r>
+            <a:r>
+              <a:rPr dirty="0"/>
+              <a:t> </a:t>
+            </a:r>
+            <a:r>
+              <a:rPr dirty="0" err="1"/>
+              <a:t>mà</a:t>
+            </a:r>
+            <a:r>
+              <a:rPr dirty="0"/>
+              <a:t> </a:t>
+            </a:r>
+            <a:r>
+              <a:rPr dirty="0" err="1"/>
+              <a:t>không</a:t>
+            </a:r>
+            <a:r>
+              <a:rPr dirty="0"/>
+              <a:t> </a:t>
+            </a:r>
+            <a:r>
+              <a:rPr dirty="0" err="1"/>
+              <a:t>cần</a:t>
+            </a:r>
+            <a:r>
+              <a:rPr dirty="0"/>
+              <a:t> </a:t>
+            </a:r>
+            <a:r>
+              <a:rPr dirty="0" err="1"/>
+              <a:t>chạm</a:t>
+            </a:r>
+            <a:r>
+              <a:rPr dirty="0"/>
+              <a:t> </a:t>
+            </a:r>
+            <a:r>
+              <a:rPr dirty="0" err="1"/>
+              <a:t>tay</a:t>
+            </a:r>
+            <a:r>
+              <a:rPr dirty="0"/>
+              <a:t> </a:t>
+            </a:r>
+            <a:r>
+              <a:rPr dirty="0" err="1"/>
+              <a:t>ướt</a:t>
+            </a:r>
+            <a:r>
+              <a:rPr dirty="0"/>
+              <a:t>/</a:t>
+            </a:r>
+            <a:r>
+              <a:rPr dirty="0" err="1"/>
+              <a:t>bẩn</a:t>
+            </a:r>
+            <a:r>
+              <a:rPr dirty="0"/>
+              <a:t> </a:t>
+            </a:r>
+            <a:r>
+              <a:rPr dirty="0" err="1"/>
+              <a:t>vào</a:t>
+            </a:r>
+            <a:r>
+              <a:rPr dirty="0"/>
+              <a:t> </a:t>
+            </a:r>
+            <a:r>
+              <a:rPr dirty="0" err="1"/>
+              <a:t>màn</a:t>
+            </a:r>
+            <a:r>
+              <a:rPr dirty="0"/>
+              <a:t> </a:t>
+            </a:r>
+            <a:r>
+              <a:rPr dirty="0" err="1"/>
+              <a:t>hình</a:t>
+            </a:r>
+            <a:r>
+              <a:rPr dirty="0"/>
+              <a:t>.</a:t>
             </a:r>
           </a:p>
           <a:p>
@@ -7802,7 +8855,160 @@
               </a:defRPr>
             </a:pPr>
             <a:r>
-              <a:t>•  Đọc to công thức (Text-to-Speech): Trợ lý ảo đọc to từng bước nấu nướng với giọng đọc tiếng Việt truyền cảm, thân thiện.</a:t>
+              <a:rPr dirty="0"/>
+              <a:t>•  </a:t>
+            </a:r>
+            <a:r>
+              <a:rPr dirty="0" err="1"/>
+              <a:t>Đọc</a:t>
+            </a:r>
+            <a:r>
+              <a:rPr dirty="0"/>
+              <a:t> to </a:t>
+            </a:r>
+            <a:r>
+              <a:rPr dirty="0" err="1"/>
+              <a:t>công</a:t>
+            </a:r>
+            <a:r>
+              <a:rPr dirty="0"/>
+              <a:t> </a:t>
+            </a:r>
+            <a:r>
+              <a:rPr dirty="0" err="1"/>
+              <a:t>thức</a:t>
+            </a:r>
+            <a:r>
+              <a:rPr dirty="0"/>
+              <a:t> (Text-to-Speech): </a:t>
+            </a:r>
+            <a:r>
+              <a:rPr dirty="0" err="1"/>
+              <a:t>Trợ</a:t>
+            </a:r>
+            <a:r>
+              <a:rPr dirty="0"/>
+              <a:t> </a:t>
+            </a:r>
+            <a:r>
+              <a:rPr dirty="0" err="1"/>
+              <a:t>lý</a:t>
+            </a:r>
+            <a:r>
+              <a:rPr dirty="0"/>
+              <a:t> </a:t>
+            </a:r>
+            <a:r>
+              <a:rPr dirty="0" err="1"/>
+              <a:t>ảo</a:t>
+            </a:r>
+            <a:r>
+              <a:rPr dirty="0"/>
+              <a:t> </a:t>
+            </a:r>
+            <a:r>
+              <a:rPr dirty="0" err="1"/>
+              <a:t>đọc</a:t>
+            </a:r>
+            <a:r>
+              <a:rPr dirty="0"/>
+              <a:t> to </a:t>
+            </a:r>
+            <a:r>
+              <a:rPr dirty="0" err="1"/>
+              <a:t>từng</a:t>
+            </a:r>
+            <a:r>
+              <a:rPr dirty="0"/>
+              <a:t> </a:t>
+            </a:r>
+            <a:r>
+              <a:rPr dirty="0" err="1"/>
+              <a:t>bước</a:t>
+            </a:r>
+            <a:r>
+              <a:rPr dirty="0"/>
+              <a:t> </a:t>
+            </a:r>
+            <a:r>
+              <a:rPr dirty="0" err="1"/>
+              <a:t>nấu</a:t>
+            </a:r>
+            <a:r>
+              <a:rPr dirty="0"/>
+              <a:t> </a:t>
+            </a:r>
+            <a:r>
+              <a:rPr dirty="0" err="1"/>
+              <a:t>nướng</a:t>
+            </a:r>
+            <a:r>
+              <a:rPr dirty="0"/>
+              <a:t> </a:t>
+            </a:r>
+            <a:r>
+              <a:rPr dirty="0" err="1"/>
+              <a:t>với</a:t>
+            </a:r>
+            <a:r>
+              <a:rPr dirty="0"/>
+              <a:t> </a:t>
+            </a:r>
+            <a:r>
+              <a:rPr dirty="0" err="1"/>
+              <a:t>giọng</a:t>
+            </a:r>
+            <a:r>
+              <a:rPr dirty="0"/>
+              <a:t> </a:t>
+            </a:r>
+            <a:r>
+              <a:rPr dirty="0" err="1"/>
+              <a:t>đọc</a:t>
+            </a:r>
+            <a:r>
+              <a:rPr dirty="0"/>
+              <a:t> </a:t>
+            </a:r>
+            <a:r>
+              <a:rPr dirty="0" err="1"/>
+              <a:t>tiếng</a:t>
+            </a:r>
+            <a:r>
+              <a:rPr dirty="0"/>
+              <a:t> Việt </a:t>
+            </a:r>
+            <a:r>
+              <a:rPr dirty="0" err="1"/>
+              <a:t>truyền</a:t>
+            </a:r>
+            <a:r>
+              <a:rPr dirty="0"/>
+              <a:t> </a:t>
+            </a:r>
+            <a:r>
+              <a:rPr dirty="0" err="1"/>
+              <a:t>cảm</a:t>
+            </a:r>
+            <a:r>
+              <a:rPr dirty="0"/>
+              <a:t>, </a:t>
+            </a:r>
+            <a:r>
+              <a:rPr dirty="0" err="1"/>
+              <a:t>thân</a:t>
+            </a:r>
+            <a:r>
+              <a:rPr dirty="0"/>
+              <a:t> </a:t>
+            </a:r>
+            <a:r>
+              <a:rPr dirty="0" err="1"/>
+              <a:t>thiện</a:t>
+            </a:r>
+            <a:r>
+              <a:rPr dirty="0"/>
+              <a:t>.</a:t>
             </a:r>
           </a:p>
           <a:p>
@@ -7817,7 +9023,200 @@
               </a:defRPr>
             </a:pPr>
             <a:r>
-              <a:t>•  Gợi ý thực đơn cá nhân hóa: Lập kế hoạch bữa ăn thông minh cả tuần theo chế độ ăn kiêng (Keto, Low-Carb, Ăn chay, Tiểu đường).</a:t>
+              <a:rPr dirty="0"/>
+              <a:t>•  </a:t>
+            </a:r>
+            <a:r>
+              <a:rPr dirty="0" err="1"/>
+              <a:t>Gợi</a:t>
+            </a:r>
+            <a:r>
+              <a:rPr dirty="0"/>
+              <a:t> ý </a:t>
+            </a:r>
+            <a:r>
+              <a:rPr dirty="0" err="1"/>
+              <a:t>thực</a:t>
+            </a:r>
+            <a:r>
+              <a:rPr dirty="0"/>
+              <a:t> </a:t>
+            </a:r>
+            <a:r>
+              <a:rPr dirty="0" err="1"/>
+              <a:t>đơn</a:t>
+            </a:r>
+            <a:r>
+              <a:rPr dirty="0"/>
+              <a:t> </a:t>
+            </a:r>
+            <a:r>
+              <a:rPr dirty="0" err="1"/>
+              <a:t>cá</a:t>
+            </a:r>
+            <a:r>
+              <a:rPr dirty="0"/>
+              <a:t> </a:t>
+            </a:r>
+            <a:r>
+              <a:rPr dirty="0" err="1"/>
+              <a:t>nhân</a:t>
+            </a:r>
+            <a:r>
+              <a:rPr dirty="0"/>
+              <a:t> </a:t>
+            </a:r>
+            <a:r>
+              <a:rPr dirty="0" err="1"/>
+              <a:t>hóa</a:t>
+            </a:r>
+            <a:r>
+              <a:rPr dirty="0"/>
+              <a:t>: </a:t>
+            </a:r>
+            <a:r>
+              <a:rPr dirty="0" err="1"/>
+              <a:t>Lập</a:t>
+            </a:r>
+            <a:r>
+              <a:rPr dirty="0"/>
+              <a:t> </a:t>
+            </a:r>
+            <a:r>
+              <a:rPr dirty="0" err="1"/>
+              <a:t>kế</a:t>
+            </a:r>
+            <a:r>
+              <a:rPr dirty="0"/>
+              <a:t> </a:t>
+            </a:r>
+            <a:r>
+              <a:rPr dirty="0" err="1"/>
+              <a:t>hoạch</a:t>
+            </a:r>
+            <a:r>
+              <a:rPr dirty="0"/>
+              <a:t> </a:t>
+            </a:r>
+            <a:r>
+              <a:rPr dirty="0" err="1"/>
+              <a:t>bữa</a:t>
+            </a:r>
+            <a:r>
+              <a:rPr dirty="0"/>
+              <a:t> </a:t>
+            </a:r>
+            <a:r>
+              <a:rPr dirty="0" err="1"/>
+              <a:t>ăn</a:t>
+            </a:r>
+            <a:r>
+              <a:rPr dirty="0"/>
+              <a:t> </a:t>
+            </a:r>
+            <a:r>
+              <a:rPr dirty="0" err="1"/>
+              <a:t>thông</a:t>
+            </a:r>
+            <a:r>
+              <a:rPr dirty="0"/>
+              <a:t> </a:t>
+            </a:r>
+            <a:r>
+              <a:rPr dirty="0" err="1"/>
+              <a:t>minh</a:t>
+            </a:r>
+            <a:r>
+              <a:rPr dirty="0"/>
+              <a:t> </a:t>
+            </a:r>
+            <a:r>
+              <a:rPr dirty="0" err="1"/>
+              <a:t>cả</a:t>
+            </a:r>
+            <a:r>
+              <a:rPr dirty="0"/>
+              <a:t> </a:t>
+            </a:r>
+            <a:r>
+              <a:rPr dirty="0" err="1"/>
+              <a:t>tuần</a:t>
+            </a:r>
+            <a:r>
+              <a:rPr dirty="0"/>
+              <a:t> </a:t>
+            </a:r>
+            <a:r>
+              <a:rPr dirty="0" err="1"/>
+              <a:t>theo</a:t>
+            </a:r>
+            <a:r>
+              <a:rPr dirty="0"/>
+              <a:t> </a:t>
+            </a:r>
+            <a:r>
+              <a:rPr dirty="0" err="1"/>
+              <a:t>chế</a:t>
+            </a:r>
+            <a:r>
+              <a:rPr dirty="0"/>
+              <a:t> </a:t>
+            </a:r>
+            <a:r>
+              <a:rPr dirty="0" err="1"/>
+              <a:t>độ</a:t>
+            </a:r>
+            <a:r>
+              <a:rPr dirty="0"/>
+              <a:t> </a:t>
+            </a:r>
+            <a:r>
+              <a:rPr dirty="0" err="1"/>
+              <a:t>ăn</a:t>
+            </a:r>
+            <a:r>
+              <a:rPr dirty="0"/>
+              <a:t> </a:t>
+            </a:r>
+            <a:r>
+              <a:rPr dirty="0" err="1"/>
+              <a:t>kiêng</a:t>
+            </a:r>
+            <a:r>
+              <a:rPr dirty="0"/>
+              <a:t> (Keto, Low-Carb, </a:t>
+            </a:r>
+            <a:r>
+              <a:rPr dirty="0" err="1"/>
+              <a:t>Ăn</a:t>
+            </a:r>
+            <a:r>
+              <a:rPr dirty="0"/>
+              <a:t> </a:t>
+            </a:r>
+            <a:r>
+              <a:rPr dirty="0" err="1"/>
+              <a:t>chay</a:t>
+            </a:r>
+            <a:r>
+              <a:rPr dirty="0"/>
+              <a:t>, </a:t>
+            </a:r>
+            <a:r>
+              <a:rPr dirty="0" err="1"/>
+              <a:t>Tiểu</a:t>
+            </a:r>
+            <a:r>
+              <a:rPr dirty="0"/>
+              <a:t> </a:t>
+            </a:r>
+            <a:r>
+              <a:rPr dirty="0" err="1"/>
+              <a:t>đường</a:t>
+            </a:r>
+            <a:r>
+              <a:rPr dirty="0"/>
+              <a:t>).</a:t>
             </a:r>
           </a:p>
         </p:txBody>
@@ -7864,6 +9263,7 @@
           <a:lstStyle/>
           <a:p>
             <a:pPr algn="ctr"/>
+            <a:endParaRPr/>
           </a:p>
         </p:txBody>
       </p:sp>
@@ -7876,7 +9276,7 @@
         <p:spPr>
           <a:xfrm>
             <a:off x="8348472" y="1645920"/>
-            <a:ext cx="2880360" cy="4389120"/>
+            <a:ext cx="2880360" cy="2090316"/>
           </a:xfrm>
           <a:prstGeom prst="rect">
             <a:avLst/>
@@ -7900,6 +9300,7 @@
               </a:defRPr>
             </a:pPr>
             <a:r>
+              <a:rPr dirty="0"/>
               <a:t>DÀI HẠN: NỀN TẢNG TOÀN DIỆN</a:t>
             </a:r>
           </a:p>
@@ -7908,14 +9309,39 @@
               <a:spcAft>
                 <a:spcPts val="600"/>
               </a:spcAft>
-              <a:defRPr b="1" sz="1350">
+              <a:defRPr sz="1350" b="1">
                 <a:solidFill>
                   <a:srgbClr val="E65100"/>
                 </a:solidFill>
               </a:defRPr>
             </a:pPr>
             <a:r>
-              <a:t>☁️ Đồng bộ &amp; Dinh dưỡng (6-12 tháng)</a:t>
+              <a:rPr dirty="0"/>
+              <a:t>☁️ </a:t>
+            </a:r>
+            <a:r>
+              <a:rPr dirty="0" err="1"/>
+              <a:t>Đồng</a:t>
+            </a:r>
+            <a:r>
+              <a:rPr dirty="0"/>
+              <a:t> </a:t>
+            </a:r>
+            <a:r>
+              <a:rPr dirty="0" err="1"/>
+              <a:t>bộ</a:t>
+            </a:r>
+            <a:r>
+              <a:rPr dirty="0"/>
+              <a:t> &amp; Dinh </a:t>
+            </a:r>
+            <a:r>
+              <a:rPr dirty="0" err="1"/>
+              <a:t>dưỡng</a:t>
+            </a:r>
+            <a:r>
+              <a:rPr dirty="0"/>
+              <a:t> </a:t>
             </a:r>
           </a:p>
           <a:p>
@@ -7930,7 +9356,200 @@
               </a:defRPr>
             </a:pPr>
             <a:r>
-              <a:t>•  Đồng bộ đám mây thời gian thực (Real-time Cloud Sync): Chia sẻ thực đơn và tủ lạnh chung cho mọi thành viên trong gia đình cùng theo dõi.</a:t>
+              <a:rPr dirty="0"/>
+              <a:t>•  </a:t>
+            </a:r>
+            <a:r>
+              <a:rPr dirty="0" err="1"/>
+              <a:t>Đồng</a:t>
+            </a:r>
+            <a:r>
+              <a:rPr dirty="0"/>
+              <a:t> </a:t>
+            </a:r>
+            <a:r>
+              <a:rPr dirty="0" err="1"/>
+              <a:t>bộ</a:t>
+            </a:r>
+            <a:r>
+              <a:rPr dirty="0"/>
+              <a:t> </a:t>
+            </a:r>
+            <a:r>
+              <a:rPr dirty="0" err="1"/>
+              <a:t>đám</a:t>
+            </a:r>
+            <a:r>
+              <a:rPr dirty="0"/>
+              <a:t> </a:t>
+            </a:r>
+            <a:r>
+              <a:rPr dirty="0" err="1"/>
+              <a:t>mây</a:t>
+            </a:r>
+            <a:r>
+              <a:rPr dirty="0"/>
+              <a:t> </a:t>
+            </a:r>
+            <a:r>
+              <a:rPr dirty="0" err="1"/>
+              <a:t>thời</a:t>
+            </a:r>
+            <a:r>
+              <a:rPr dirty="0"/>
+              <a:t> </a:t>
+            </a:r>
+            <a:r>
+              <a:rPr dirty="0" err="1"/>
+              <a:t>gian</a:t>
+            </a:r>
+            <a:r>
+              <a:rPr dirty="0"/>
+              <a:t> </a:t>
+            </a:r>
+            <a:r>
+              <a:rPr dirty="0" err="1"/>
+              <a:t>thực</a:t>
+            </a:r>
+            <a:r>
+              <a:rPr dirty="0"/>
+              <a:t> (Real-time Cloud Sync): Chia </a:t>
+            </a:r>
+            <a:r>
+              <a:rPr dirty="0" err="1"/>
+              <a:t>sẻ</a:t>
+            </a:r>
+            <a:r>
+              <a:rPr dirty="0"/>
+              <a:t> </a:t>
+            </a:r>
+            <a:r>
+              <a:rPr dirty="0" err="1"/>
+              <a:t>thực</a:t>
+            </a:r>
+            <a:r>
+              <a:rPr dirty="0"/>
+              <a:t> </a:t>
+            </a:r>
+            <a:r>
+              <a:rPr dirty="0" err="1"/>
+              <a:t>đơn</a:t>
+            </a:r>
+            <a:r>
+              <a:rPr dirty="0"/>
+              <a:t> </a:t>
+            </a:r>
+            <a:r>
+              <a:rPr dirty="0" err="1"/>
+              <a:t>và</a:t>
+            </a:r>
+            <a:r>
+              <a:rPr dirty="0"/>
+              <a:t> </a:t>
+            </a:r>
+            <a:r>
+              <a:rPr dirty="0" err="1"/>
+              <a:t>tủ</a:t>
+            </a:r>
+            <a:r>
+              <a:rPr dirty="0"/>
+              <a:t> </a:t>
+            </a:r>
+            <a:r>
+              <a:rPr dirty="0" err="1"/>
+              <a:t>lạnh</a:t>
+            </a:r>
+            <a:r>
+              <a:rPr dirty="0"/>
+              <a:t> </a:t>
+            </a:r>
+            <a:r>
+              <a:rPr dirty="0" err="1"/>
+              <a:t>chung</a:t>
+            </a:r>
+            <a:r>
+              <a:rPr dirty="0"/>
+              <a:t> </a:t>
+            </a:r>
+            <a:r>
+              <a:rPr dirty="0" err="1"/>
+              <a:t>cho</a:t>
+            </a:r>
+            <a:r>
+              <a:rPr dirty="0"/>
+              <a:t> </a:t>
+            </a:r>
+            <a:r>
+              <a:rPr dirty="0" err="1"/>
+              <a:t>mọi</a:t>
+            </a:r>
+            <a:r>
+              <a:rPr dirty="0"/>
+              <a:t> </a:t>
+            </a:r>
+            <a:r>
+              <a:rPr dirty="0" err="1"/>
+              <a:t>thành</a:t>
+            </a:r>
+            <a:r>
+              <a:rPr dirty="0"/>
+              <a:t> </a:t>
+            </a:r>
+            <a:r>
+              <a:rPr dirty="0" err="1"/>
+              <a:t>viên</a:t>
+            </a:r>
+            <a:r>
+              <a:rPr dirty="0"/>
+              <a:t> </a:t>
+            </a:r>
+            <a:r>
+              <a:rPr dirty="0" err="1"/>
+              <a:t>trong</a:t>
+            </a:r>
+            <a:r>
+              <a:rPr dirty="0"/>
+              <a:t> </a:t>
+            </a:r>
+            <a:r>
+              <a:rPr dirty="0" err="1"/>
+              <a:t>gia</a:t>
+            </a:r>
+            <a:r>
+              <a:rPr dirty="0"/>
+              <a:t> </a:t>
+            </a:r>
+            <a:r>
+              <a:rPr dirty="0" err="1"/>
+              <a:t>đình</a:t>
+            </a:r>
+            <a:r>
+              <a:rPr dirty="0"/>
+              <a:t> </a:t>
+            </a:r>
+            <a:r>
+              <a:rPr dirty="0" err="1"/>
+              <a:t>cùng</a:t>
+            </a:r>
+            <a:r>
+              <a:rPr dirty="0"/>
+              <a:t> </a:t>
+            </a:r>
+            <a:r>
+              <a:rPr dirty="0" err="1"/>
+              <a:t>theo</a:t>
+            </a:r>
+            <a:r>
+              <a:rPr dirty="0"/>
+              <a:t> </a:t>
+            </a:r>
+            <a:r>
+              <a:rPr dirty="0" err="1"/>
+              <a:t>dõi</a:t>
+            </a:r>
+            <a:r>
+              <a:rPr dirty="0"/>
+              <a:t>.</a:t>
             </a:r>
           </a:p>
           <a:p>
@@ -7945,7 +9564,176 @@
               </a:defRPr>
             </a:pPr>
             <a:r>
-              <a:t>•  Phân tích dinh dưỡng chuyên sâu: Tự động tính toán tổng lượng Calo, Protein, Carb, Fat dựa trên khối lượng nguyên liệu trong món ăn.</a:t>
+              <a:rPr dirty="0"/>
+              <a:t>•  </a:t>
+            </a:r>
+            <a:r>
+              <a:rPr dirty="0" err="1"/>
+              <a:t>Phân</a:t>
+            </a:r>
+            <a:r>
+              <a:rPr dirty="0"/>
+              <a:t> </a:t>
+            </a:r>
+            <a:r>
+              <a:rPr dirty="0" err="1"/>
+              <a:t>tích</a:t>
+            </a:r>
+            <a:r>
+              <a:rPr dirty="0"/>
+              <a:t> </a:t>
+            </a:r>
+            <a:r>
+              <a:rPr dirty="0" err="1"/>
+              <a:t>dinh</a:t>
+            </a:r>
+            <a:r>
+              <a:rPr dirty="0"/>
+              <a:t> </a:t>
+            </a:r>
+            <a:r>
+              <a:rPr dirty="0" err="1"/>
+              <a:t>dưỡng</a:t>
+            </a:r>
+            <a:r>
+              <a:rPr dirty="0"/>
+              <a:t> </a:t>
+            </a:r>
+            <a:r>
+              <a:rPr dirty="0" err="1"/>
+              <a:t>chuyên</a:t>
+            </a:r>
+            <a:r>
+              <a:rPr dirty="0"/>
+              <a:t> </a:t>
+            </a:r>
+            <a:r>
+              <a:rPr dirty="0" err="1"/>
+              <a:t>sâu</a:t>
+            </a:r>
+            <a:r>
+              <a:rPr dirty="0"/>
+              <a:t>: </a:t>
+            </a:r>
+            <a:r>
+              <a:rPr dirty="0" err="1"/>
+              <a:t>Tự</a:t>
+            </a:r>
+            <a:r>
+              <a:rPr dirty="0"/>
+              <a:t> </a:t>
+            </a:r>
+            <a:r>
+              <a:rPr dirty="0" err="1"/>
+              <a:t>động</a:t>
+            </a:r>
+            <a:r>
+              <a:rPr dirty="0"/>
+              <a:t> </a:t>
+            </a:r>
+            <a:r>
+              <a:rPr dirty="0" err="1"/>
+              <a:t>tính</a:t>
+            </a:r>
+            <a:r>
+              <a:rPr dirty="0"/>
+              <a:t> </a:t>
+            </a:r>
+            <a:r>
+              <a:rPr dirty="0" err="1"/>
+              <a:t>toán</a:t>
+            </a:r>
+            <a:r>
+              <a:rPr dirty="0"/>
+              <a:t> </a:t>
+            </a:r>
+            <a:r>
+              <a:rPr dirty="0" err="1"/>
+              <a:t>tổng</a:t>
+            </a:r>
+            <a:r>
+              <a:rPr dirty="0"/>
+              <a:t> </a:t>
+            </a:r>
+            <a:r>
+              <a:rPr dirty="0" err="1"/>
+              <a:t>lượng</a:t>
+            </a:r>
+            <a:r>
+              <a:rPr dirty="0"/>
+              <a:t> Calo, Protein, Carb, Fat </a:t>
+            </a:r>
+            <a:r>
+              <a:rPr dirty="0" err="1"/>
+              <a:t>dựa</a:t>
+            </a:r>
+            <a:r>
+              <a:rPr dirty="0"/>
+              <a:t> </a:t>
+            </a:r>
+            <a:r>
+              <a:rPr dirty="0" err="1"/>
+              <a:t>trên</a:t>
+            </a:r>
+            <a:r>
+              <a:rPr dirty="0"/>
+              <a:t> </a:t>
+            </a:r>
+            <a:r>
+              <a:rPr dirty="0" err="1"/>
+              <a:t>khối</a:t>
+            </a:r>
+            <a:r>
+              <a:rPr dirty="0"/>
+              <a:t> </a:t>
+            </a:r>
+            <a:r>
+              <a:rPr dirty="0" err="1"/>
+              <a:t>lượng</a:t>
+            </a:r>
+            <a:r>
+              <a:rPr dirty="0"/>
+              <a:t> </a:t>
+            </a:r>
+            <a:r>
+              <a:rPr dirty="0" err="1"/>
+              <a:t>nguyên</a:t>
+            </a:r>
+            <a:r>
+              <a:rPr dirty="0"/>
+              <a:t> </a:t>
+            </a:r>
+            <a:r>
+              <a:rPr dirty="0" err="1"/>
+              <a:t>liệu</a:t>
+            </a:r>
+            <a:r>
+              <a:rPr dirty="0"/>
+              <a:t> </a:t>
+            </a:r>
+            <a:r>
+              <a:rPr dirty="0" err="1"/>
+              <a:t>trong</a:t>
+            </a:r>
+            <a:r>
+              <a:rPr dirty="0"/>
+              <a:t> </a:t>
+            </a:r>
+            <a:r>
+              <a:rPr dirty="0" err="1"/>
+              <a:t>món</a:t>
+            </a:r>
+            <a:r>
+              <a:rPr dirty="0"/>
+              <a:t> </a:t>
+            </a:r>
+            <a:r>
+              <a:rPr dirty="0" err="1"/>
+              <a:t>ăn</a:t>
+            </a:r>
+            <a:r>
+              <a:rPr dirty="0"/>
+              <a:t>.</a:t>
             </a:r>
           </a:p>
           <a:p>
@@ -7960,7 +9748,208 @@
               </a:defRPr>
             </a:pPr>
             <a:r>
-              <a:t>•  Xây dựng mạng xã hội ẩm thực: Cho phép người dùng xuất bản, chia sẻ và đánh giá công thức nấu nướng của cộng đồng nội trợ.</a:t>
+              <a:rPr dirty="0"/>
+              <a:t>•  </a:t>
+            </a:r>
+            <a:r>
+              <a:rPr dirty="0" err="1"/>
+              <a:t>Xây</a:t>
+            </a:r>
+            <a:r>
+              <a:rPr dirty="0"/>
+              <a:t> </a:t>
+            </a:r>
+            <a:r>
+              <a:rPr dirty="0" err="1"/>
+              <a:t>dựng</a:t>
+            </a:r>
+            <a:r>
+              <a:rPr dirty="0"/>
+              <a:t> </a:t>
+            </a:r>
+            <a:r>
+              <a:rPr dirty="0" err="1"/>
+              <a:t>mạng</a:t>
+            </a:r>
+            <a:r>
+              <a:rPr dirty="0"/>
+              <a:t> </a:t>
+            </a:r>
+            <a:r>
+              <a:rPr dirty="0" err="1"/>
+              <a:t>xã</a:t>
+            </a:r>
+            <a:r>
+              <a:rPr dirty="0"/>
+              <a:t> </a:t>
+            </a:r>
+            <a:r>
+              <a:rPr dirty="0" err="1"/>
+              <a:t>hội</a:t>
+            </a:r>
+            <a:r>
+              <a:rPr dirty="0"/>
+              <a:t> </a:t>
+            </a:r>
+            <a:r>
+              <a:rPr dirty="0" err="1"/>
+              <a:t>ẩm</a:t>
+            </a:r>
+            <a:r>
+              <a:rPr dirty="0"/>
+              <a:t> </a:t>
+            </a:r>
+            <a:r>
+              <a:rPr dirty="0" err="1"/>
+              <a:t>thực</a:t>
+            </a:r>
+            <a:r>
+              <a:rPr dirty="0"/>
+              <a:t>: Cho </a:t>
+            </a:r>
+            <a:r>
+              <a:rPr dirty="0" err="1"/>
+              <a:t>phép</a:t>
+            </a:r>
+            <a:r>
+              <a:rPr dirty="0"/>
+              <a:t> </a:t>
+            </a:r>
+            <a:r>
+              <a:rPr dirty="0" err="1"/>
+              <a:t>người</a:t>
+            </a:r>
+            <a:r>
+              <a:rPr dirty="0"/>
+              <a:t> </a:t>
+            </a:r>
+            <a:r>
+              <a:rPr dirty="0" err="1"/>
+              <a:t>dùng</a:t>
+            </a:r>
+            <a:r>
+              <a:rPr dirty="0"/>
+              <a:t> </a:t>
+            </a:r>
+            <a:r>
+              <a:rPr dirty="0" err="1"/>
+              <a:t>xuất</a:t>
+            </a:r>
+            <a:r>
+              <a:rPr dirty="0"/>
+              <a:t> </a:t>
+            </a:r>
+            <a:r>
+              <a:rPr dirty="0" err="1"/>
+              <a:t>bản</a:t>
+            </a:r>
+            <a:r>
+              <a:rPr dirty="0"/>
+              <a:t>, chia </a:t>
+            </a:r>
+            <a:r>
+              <a:rPr dirty="0" err="1"/>
+              <a:t>sẻ</a:t>
+            </a:r>
+            <a:r>
+              <a:rPr dirty="0"/>
+              <a:t> </a:t>
+            </a:r>
+            <a:r>
+              <a:rPr dirty="0" err="1"/>
+              <a:t>và</a:t>
+            </a:r>
+            <a:r>
+              <a:rPr dirty="0"/>
+              <a:t> </a:t>
+            </a:r>
+            <a:r>
+              <a:rPr dirty="0" err="1"/>
+              <a:t>đánh</a:t>
+            </a:r>
+            <a:r>
+              <a:rPr dirty="0"/>
+              <a:t> </a:t>
+            </a:r>
+            <a:r>
+              <a:rPr dirty="0" err="1"/>
+              <a:t>giá</a:t>
+            </a:r>
+            <a:r>
+              <a:rPr dirty="0"/>
+              <a:t> </a:t>
+            </a:r>
+            <a:r>
+              <a:rPr dirty="0" err="1"/>
+              <a:t>công</a:t>
+            </a:r>
+            <a:r>
+              <a:rPr dirty="0"/>
+              <a:t> </a:t>
+            </a:r>
+            <a:r>
+              <a:rPr dirty="0" err="1"/>
+              <a:t>thức</a:t>
+            </a:r>
+            <a:r>
+              <a:rPr dirty="0"/>
+              <a:t> </a:t>
+            </a:r>
+            <a:r>
+              <a:rPr dirty="0" err="1"/>
+              <a:t>nấu</a:t>
+            </a:r>
+            <a:r>
+              <a:rPr dirty="0"/>
+              <a:t> </a:t>
+            </a:r>
+            <a:r>
+              <a:rPr dirty="0" err="1"/>
+              <a:t>nướng</a:t>
+            </a:r>
+            <a:r>
+              <a:rPr dirty="0"/>
+              <a:t> </a:t>
+            </a:r>
+            <a:r>
+              <a:rPr dirty="0" err="1"/>
+              <a:t>của</a:t>
+            </a:r>
+            <a:r>
+              <a:rPr dirty="0"/>
+              <a:t> </a:t>
+            </a:r>
+            <a:r>
+              <a:rPr dirty="0" err="1"/>
+              <a:t>cộng</a:t>
+            </a:r>
+            <a:r>
+              <a:rPr dirty="0"/>
+              <a:t> </a:t>
+            </a:r>
+            <a:r>
+              <a:rPr dirty="0" err="1"/>
+              <a:t>đồng</a:t>
+            </a:r>
+            <a:r>
+              <a:rPr dirty="0"/>
+              <a:t> </a:t>
+            </a:r>
+            <a:r>
+              <a:rPr dirty="0" err="1"/>
+              <a:t>nội</a:t>
+            </a:r>
+            <a:r>
+              <a:rPr dirty="0"/>
+              <a:t> </a:t>
+            </a:r>
+            <a:r>
+              <a:rPr dirty="0" err="1"/>
+              <a:t>trợ</a:t>
+            </a:r>
+            <a:r>
+              <a:rPr dirty="0"/>
+              <a:t>.</a:t>
             </a:r>
           </a:p>
         </p:txBody>
@@ -7974,7 +9963,7 @@
 </file>
 
 <file path=ppt/slides/slide16.xml><?xml version="1.0" encoding="utf-8"?>
-<p:sld xmlns:a="http://schemas.openxmlformats.org/drawingml/2006/main" xmlns:p="http://schemas.openxmlformats.org/presentationml/2006/main" xmlns:r="http://schemas.openxmlformats.org/officeDocument/2006/relationships">
+<p:sld xmlns:a="http://schemas.openxmlformats.org/drawingml/2006/main" xmlns:r="http://schemas.openxmlformats.org/officeDocument/2006/relationships" xmlns:p="http://schemas.openxmlformats.org/presentationml/2006/main">
   <p:cSld>
     <p:spTree>
       <p:nvGrpSpPr>
@@ -7982,7 +9971,14 @@
         <p:cNvGrpSpPr/>
         <p:nvPr/>
       </p:nvGrpSpPr>
-      <p:grpSpPr/>
+      <p:grpSpPr>
+        <a:xfrm>
+          <a:off x="0" y="0"/>
+          <a:ext cx="0" cy="0"/>
+          <a:chOff x="0" y="0"/>
+          <a:chExt cx="0" cy="0"/>
+        </a:xfrm>
+      </p:grpSpPr>
       <p:sp>
         <p:nvSpPr>
           <p:cNvPr id="2" name="Rectangle 1"/>
@@ -8023,6 +10019,7 @@
           <a:lstStyle/>
           <a:p>
             <a:pPr algn="ctr"/>
+            <a:endParaRPr/>
           </a:p>
         </p:txBody>
       </p:sp>
@@ -8066,6 +10063,7 @@
           <a:lstStyle/>
           <a:p>
             <a:pPr algn="ctr"/>
+            <a:endParaRPr/>
           </a:p>
         </p:txBody>
       </p:sp>
@@ -8077,8 +10075,8 @@
         </p:nvSpPr>
         <p:spPr>
           <a:xfrm>
-            <a:off x="731520" y="731520"/>
-            <a:ext cx="10728655" cy="2011680"/>
+            <a:off x="612648" y="2898648"/>
+            <a:ext cx="10728655" cy="1056700"/>
           </a:xfrm>
           <a:prstGeom prst="rect">
             <a:avLst/>
@@ -8102,138 +10100,27 @@
               </a:defRPr>
             </a:pPr>
             <a:r>
-              <a:t>XIN CHÂN THÀNH CẢM ƠN HỘI ĐỒNG &amp; QUÝ THẦY CÔ!</a:t>
-            </a:r>
+              <a:rPr dirty="0"/>
+              <a:t>XIN CHÂN THÀNH CẢM ƠN THẦY CÔ!</a:t>
+            </a:r>
+            <a:endParaRPr lang="en-US" dirty="0"/>
           </a:p>
           <a:p>
             <a:pPr algn="ctr">
-              <a:defRPr sz="1400">
-                <a:solidFill>
-                  <a:srgbClr val="93C5FD"/>
-                </a:solidFill>
-              </a:defRPr>
-            </a:pPr>
-            <a:r>
-              <a:t>Nhóm xin gửi lời tri ân sâu sắc tới ThS. Lê Văn Quân đã tận tình hướng dẫn và định hướng chuyên môn cho đồ án Cooking Note.</a:t>
-            </a:r>
-          </a:p>
-        </p:txBody>
-      </p:sp>
-      <p:sp>
-        <p:nvSpPr>
-          <p:cNvPr id="5" name="Rounded Rectangle 4"/>
-          <p:cNvSpPr/>
-          <p:nvPr/>
-        </p:nvSpPr>
-        <p:spPr>
-          <a:xfrm>
-            <a:off x="1645920" y="2926080"/>
-            <a:ext cx="8899855" cy="3291840"/>
-          </a:xfrm>
-          <a:prstGeom prst="roundRect">
-            <a:avLst/>
-          </a:prstGeom>
-          <a:solidFill>
-            <a:srgbClr val="0F2D42"/>
-          </a:solidFill>
-          <a:ln w="19050">
-            <a:solidFill>
-              <a:srgbClr val="3B82F6"/>
-            </a:solidFill>
-          </a:ln>
-        </p:spPr>
-        <p:style>
-          <a:lnRef idx="1">
-            <a:schemeClr val="accent1"/>
-          </a:lnRef>
-          <a:fillRef idx="3">
-            <a:schemeClr val="accent1"/>
-          </a:fillRef>
-          <a:effectRef idx="2">
-            <a:schemeClr val="accent1"/>
-          </a:effectRef>
-          <a:fontRef idx="minor">
-            <a:schemeClr val="lt1"/>
-          </a:fontRef>
-        </p:style>
-        <p:txBody>
-          <a:bodyPr rtlCol="0" anchor="ctr"/>
-          <a:lstStyle/>
-          <a:p>
-            <a:pPr algn="ctr"/>
-          </a:p>
-        </p:txBody>
-      </p:sp>
-      <p:sp>
-        <p:nvSpPr>
-          <p:cNvPr id="6" name="TextBox 5"/>
-          <p:cNvSpPr txBox="1"/>
-          <p:nvPr/>
-        </p:nvSpPr>
-        <p:spPr>
-          <a:xfrm>
-            <a:off x="1920240" y="3108960"/>
-            <a:ext cx="8351215" cy="2926080"/>
-          </a:xfrm>
-          <a:prstGeom prst="rect">
-            <a:avLst/>
-          </a:prstGeom>
-          <a:noFill/>
-        </p:spPr>
-        <p:txBody>
-          <a:bodyPr wrap="square">
-            <a:spAutoFit/>
-          </a:bodyPr>
-          <a:lstStyle/>
-          <a:p>
-            <a:pPr algn="ctr">
-              <a:spcAft>
-                <a:spcPts val="1400"/>
-              </a:spcAft>
-              <a:defRPr sz="2000" b="1">
-                <a:solidFill>
-                  <a:srgbClr val="FBBF24"/>
-                </a:solidFill>
-              </a:defRPr>
-            </a:pPr>
-            <a:r>
-              <a:t>PHIÊN HỎI ĐÁP &amp; BẢO VỆ ĐỒ ÁN (Q&amp;A)</a:t>
-            </a:r>
-          </a:p>
-          <a:p>
-            <a:pPr algn="ctr">
-              <a:spcAft>
-                <a:spcPts val="1400"/>
-              </a:spcAft>
-              <a:defRPr sz="1350">
+              <a:spcAft>
+                <a:spcPts val="800"/>
+              </a:spcAft>
+              <a:defRPr sz="2800" b="1">
                 <a:solidFill>
                   <a:srgbClr val="FFFFFF"/>
                 </a:solidFill>
               </a:defRPr>
             </a:pPr>
             <a:r>
-              <a:t>Nhóm sinh viên thực hiện đã sẵn sàng lắng nghe các câu hỏi, góp ý quý báu và phản biện chuyên môn từ Hội đồng chấm thi.</a:t>
-            </a:r>
-          </a:p>
-          <a:p>
-            <a:pPr algn="ctr">
-              <a:defRPr sz="1200">
-                <a:solidFill>
-                  <a:srgbClr val="E2E8F0"/>
-                </a:solidFill>
-              </a:defRPr>
-            </a:pPr>
-            <a:r>
-              <a:t>✦ Nhóm thực hiện: Vũ Đình Đạo (Nhóm trưởng) • Ngô Gia Bảo • Nguyễn Tiến Dũng • Lê Đức Trọng</a:t>
-            </a:r>
-            <a:br/>
-            <a:r>
-              <a:t>✦ Lớp: TT602-K16LT  |  Khoa Công nghệ Thông tin — CBK</a:t>
-            </a:r>
-            <a:br/>
-            <a:r>
-              <a:t>✦ Mã nguồn &amp; Báo cáo kỹ thuật: Đã kiểm chứng 135/135 Unit Tests tự động vượt qua 100%</a:t>
-            </a:r>
+              <a:rPr lang="en-US" dirty="0"/>
+              <a:t>ĐÃ THEO DÕI BÀI THUYẾT TRÌNH NÀY CỦA CHÚNG EM</a:t>
+            </a:r>
+            <a:endParaRPr dirty="0"/>
           </a:p>
         </p:txBody>
       </p:sp>
@@ -8246,7 +10133,7 @@
 </file>
 
 <file path=ppt/slides/slide2.xml><?xml version="1.0" encoding="utf-8"?>
-<p:sld xmlns:a="http://schemas.openxmlformats.org/drawingml/2006/main" xmlns:p="http://schemas.openxmlformats.org/presentationml/2006/main" xmlns:r="http://schemas.openxmlformats.org/officeDocument/2006/relationships">
+<p:sld xmlns:a="http://schemas.openxmlformats.org/drawingml/2006/main" xmlns:r="http://schemas.openxmlformats.org/officeDocument/2006/relationships" xmlns:p="http://schemas.openxmlformats.org/presentationml/2006/main">
   <p:cSld>
     <p:spTree>
       <p:nvGrpSpPr>
@@ -8254,7 +10141,14 @@
         <p:cNvGrpSpPr/>
         <p:nvPr/>
       </p:nvGrpSpPr>
-      <p:grpSpPr/>
+      <p:grpSpPr>
+        <a:xfrm>
+          <a:off x="0" y="0"/>
+          <a:ext cx="0" cy="0"/>
+          <a:chOff x="0" y="0"/>
+          <a:chExt cx="0" cy="0"/>
+        </a:xfrm>
+      </p:grpSpPr>
       <p:sp>
         <p:nvSpPr>
           <p:cNvPr id="2" name="Rectangle 1"/>
@@ -8295,6 +10189,7 @@
           <a:lstStyle/>
           <a:p>
             <a:pPr algn="ctr"/>
+            <a:endParaRPr/>
           </a:p>
         </p:txBody>
       </p:sp>
@@ -8443,6 +10338,7 @@
           <a:lstStyle/>
           <a:p>
             <a:pPr algn="ctr"/>
+            <a:endParaRPr/>
           </a:p>
         </p:txBody>
       </p:sp>
@@ -8523,6 +10419,7 @@
           <a:lstStyle/>
           <a:p>
             <a:pPr algn="ctr"/>
+            <a:endParaRPr/>
           </a:p>
         </p:txBody>
       </p:sp>
@@ -8567,7 +10464,7 @@
               <a:spcAft>
                 <a:spcPts val="600"/>
               </a:spcAft>
-              <a:defRPr b="1" sz="1350">
+              <a:defRPr sz="1350" b="1">
                 <a:solidFill>
                   <a:srgbClr val="E65100"/>
                 </a:solidFill>
@@ -8681,6 +10578,7 @@
           <a:lstStyle/>
           <a:p>
             <a:pPr algn="ctr"/>
+            <a:endParaRPr/>
           </a:p>
         </p:txBody>
       </p:sp>
@@ -8725,7 +10623,7 @@
               <a:spcAft>
                 <a:spcPts val="600"/>
               </a:spcAft>
-              <a:defRPr b="1" sz="1350">
+              <a:defRPr sz="1350" b="1">
                 <a:solidFill>
                   <a:srgbClr val="0E6655"/>
                 </a:solidFill>
@@ -8806,7 +10704,7 @@
 </file>
 
 <file path=ppt/slides/slide3.xml><?xml version="1.0" encoding="utf-8"?>
-<p:sld xmlns:a="http://schemas.openxmlformats.org/drawingml/2006/main" xmlns:p="http://schemas.openxmlformats.org/presentationml/2006/main" xmlns:r="http://schemas.openxmlformats.org/officeDocument/2006/relationships">
+<p:sld xmlns:a="http://schemas.openxmlformats.org/drawingml/2006/main" xmlns:r="http://schemas.openxmlformats.org/officeDocument/2006/relationships" xmlns:p="http://schemas.openxmlformats.org/presentationml/2006/main">
   <p:cSld>
     <p:spTree>
       <p:nvGrpSpPr>
@@ -8814,7 +10712,14 @@
         <p:cNvGrpSpPr/>
         <p:nvPr/>
       </p:nvGrpSpPr>
-      <p:grpSpPr/>
+      <p:grpSpPr>
+        <a:xfrm>
+          <a:off x="0" y="0"/>
+          <a:ext cx="0" cy="0"/>
+          <a:chOff x="0" y="0"/>
+          <a:chExt cx="0" cy="0"/>
+        </a:xfrm>
+      </p:grpSpPr>
       <p:sp>
         <p:nvSpPr>
           <p:cNvPr id="2" name="Rectangle 1"/>
@@ -8855,6 +10760,7 @@
           <a:lstStyle/>
           <a:p>
             <a:pPr algn="ctr"/>
+            <a:endParaRPr/>
           </a:p>
         </p:txBody>
       </p:sp>
@@ -9003,6 +10909,7 @@
           <a:lstStyle/>
           <a:p>
             <a:pPr algn="ctr"/>
+            <a:endParaRPr/>
           </a:p>
         </p:txBody>
       </p:sp>
@@ -9083,6 +10990,7 @@
           <a:lstStyle/>
           <a:p>
             <a:pPr algn="ctr"/>
+            <a:endParaRPr/>
           </a:p>
         </p:txBody>
       </p:sp>
@@ -9127,7 +11035,7 @@
               <a:spcAft>
                 <a:spcPts val="600"/>
               </a:spcAft>
-              <a:defRPr b="1" sz="1350">
+              <a:defRPr sz="1350" b="1">
                 <a:solidFill>
                   <a:srgbClr val="1B4F72"/>
                 </a:solidFill>
@@ -9241,6 +11149,7 @@
           <a:lstStyle/>
           <a:p>
             <a:pPr algn="ctr"/>
+            <a:endParaRPr/>
           </a:p>
         </p:txBody>
       </p:sp>
@@ -9285,7 +11194,7 @@
               <a:spcAft>
                 <a:spcPts val="600"/>
               </a:spcAft>
-              <a:defRPr b="1" sz="1350">
+              <a:defRPr sz="1350" b="1">
                 <a:solidFill>
                   <a:srgbClr val="1B4F72"/>
                 </a:solidFill>
@@ -9399,6 +11308,7 @@
           <a:lstStyle/>
           <a:p>
             <a:pPr algn="ctr"/>
+            <a:endParaRPr/>
           </a:p>
         </p:txBody>
       </p:sp>
@@ -9443,7 +11353,7 @@
               <a:spcAft>
                 <a:spcPts val="600"/>
               </a:spcAft>
-              <a:defRPr b="1" sz="1350">
+              <a:defRPr sz="1350" b="1">
                 <a:solidFill>
                   <a:srgbClr val="1B4F72"/>
                 </a:solidFill>
@@ -9524,7 +11434,7 @@
 </file>
 
 <file path=ppt/slides/slide4.xml><?xml version="1.0" encoding="utf-8"?>
-<p:sld xmlns:a="http://schemas.openxmlformats.org/drawingml/2006/main" xmlns:p="http://schemas.openxmlformats.org/presentationml/2006/main" xmlns:r="http://schemas.openxmlformats.org/officeDocument/2006/relationships">
+<p:sld xmlns:a="http://schemas.openxmlformats.org/drawingml/2006/main" xmlns:r="http://schemas.openxmlformats.org/officeDocument/2006/relationships" xmlns:p="http://schemas.openxmlformats.org/presentationml/2006/main">
   <p:cSld>
     <p:spTree>
       <p:nvGrpSpPr>
@@ -9532,7 +11442,14 @@
         <p:cNvGrpSpPr/>
         <p:nvPr/>
       </p:nvGrpSpPr>
-      <p:grpSpPr/>
+      <p:grpSpPr>
+        <a:xfrm>
+          <a:off x="0" y="0"/>
+          <a:ext cx="0" cy="0"/>
+          <a:chOff x="0" y="0"/>
+          <a:chExt cx="0" cy="0"/>
+        </a:xfrm>
+      </p:grpSpPr>
       <p:sp>
         <p:nvSpPr>
           <p:cNvPr id="2" name="Rectangle 1"/>
@@ -9573,6 +11490,7 @@
           <a:lstStyle/>
           <a:p>
             <a:pPr algn="ctr"/>
+            <a:endParaRPr/>
           </a:p>
         </p:txBody>
       </p:sp>
@@ -9721,6 +11639,7 @@
           <a:lstStyle/>
           <a:p>
             <a:pPr algn="ctr"/>
+            <a:endParaRPr/>
           </a:p>
         </p:txBody>
       </p:sp>
@@ -9801,6 +11720,7 @@
           <a:lstStyle/>
           <a:p>
             <a:pPr algn="ctr"/>
+            <a:endParaRPr/>
           </a:p>
         </p:txBody>
       </p:sp>
@@ -9845,7 +11765,7 @@
               <a:spcAft>
                 <a:spcPts val="600"/>
               </a:spcAft>
-              <a:defRPr b="1" sz="1350">
+              <a:defRPr sz="1350" b="1">
                 <a:solidFill>
                   <a:srgbClr val="1B4F72"/>
                 </a:solidFill>
@@ -9944,6 +11864,7 @@
           <a:lstStyle/>
           <a:p>
             <a:pPr algn="ctr"/>
+            <a:endParaRPr/>
           </a:p>
         </p:txBody>
       </p:sp>
@@ -9988,7 +11909,7 @@
               <a:spcAft>
                 <a:spcPts val="600"/>
               </a:spcAft>
-              <a:defRPr b="1" sz="1350">
+              <a:defRPr sz="1350" b="1">
                 <a:solidFill>
                   <a:srgbClr val="1B4F72"/>
                 </a:solidFill>
@@ -10087,6 +12008,7 @@
           <a:lstStyle/>
           <a:p>
             <a:pPr algn="ctr"/>
+            <a:endParaRPr/>
           </a:p>
         </p:txBody>
       </p:sp>
@@ -10131,7 +12053,7 @@
               <a:spcAft>
                 <a:spcPts val="600"/>
               </a:spcAft>
-              <a:defRPr b="1" sz="1350">
+              <a:defRPr sz="1350" b="1">
                 <a:solidFill>
                   <a:srgbClr val="1B4F72"/>
                 </a:solidFill>
@@ -10230,6 +12152,7 @@
           <a:lstStyle/>
           <a:p>
             <a:pPr algn="ctr"/>
+            <a:endParaRPr/>
           </a:p>
         </p:txBody>
       </p:sp>
@@ -10274,7 +12197,7 @@
               <a:spcAft>
                 <a:spcPts val="600"/>
               </a:spcAft>
-              <a:defRPr b="1" sz="1350">
+              <a:defRPr sz="1350" b="1">
                 <a:solidFill>
                   <a:srgbClr val="1B4F72"/>
                 </a:solidFill>
@@ -10373,6 +12296,7 @@
           <a:lstStyle/>
           <a:p>
             <a:pPr algn="ctr"/>
+            <a:endParaRPr/>
           </a:p>
         </p:txBody>
       </p:sp>
@@ -10417,7 +12341,7 @@
               <a:spcAft>
                 <a:spcPts val="600"/>
               </a:spcAft>
-              <a:defRPr b="1" sz="1350">
+              <a:defRPr sz="1350" b="1">
                 <a:solidFill>
                   <a:srgbClr val="1B4F72"/>
                 </a:solidFill>
@@ -10483,7 +12407,7 @@
 </file>
 
 <file path=ppt/slides/slide5.xml><?xml version="1.0" encoding="utf-8"?>
-<p:sld xmlns:a="http://schemas.openxmlformats.org/drawingml/2006/main" xmlns:p="http://schemas.openxmlformats.org/presentationml/2006/main" xmlns:r="http://schemas.openxmlformats.org/officeDocument/2006/relationships">
+<p:sld xmlns:a="http://schemas.openxmlformats.org/drawingml/2006/main" xmlns:r="http://schemas.openxmlformats.org/officeDocument/2006/relationships" xmlns:p="http://schemas.openxmlformats.org/presentationml/2006/main">
   <p:cSld>
     <p:spTree>
       <p:nvGrpSpPr>
@@ -10491,7 +12415,14 @@
         <p:cNvGrpSpPr/>
         <p:nvPr/>
       </p:nvGrpSpPr>
-      <p:grpSpPr/>
+      <p:grpSpPr>
+        <a:xfrm>
+          <a:off x="0" y="0"/>
+          <a:ext cx="0" cy="0"/>
+          <a:chOff x="0" y="0"/>
+          <a:chExt cx="0" cy="0"/>
+        </a:xfrm>
+      </p:grpSpPr>
       <p:sp>
         <p:nvSpPr>
           <p:cNvPr id="2" name="Rectangle 1"/>
@@ -10532,6 +12463,7 @@
           <a:lstStyle/>
           <a:p>
             <a:pPr algn="ctr"/>
+            <a:endParaRPr/>
           </a:p>
         </p:txBody>
       </p:sp>
@@ -10680,6 +12612,7 @@
           <a:lstStyle/>
           <a:p>
             <a:pPr algn="ctr"/>
+            <a:endParaRPr/>
           </a:p>
         </p:txBody>
       </p:sp>
@@ -10760,6 +12693,7 @@
           <a:lstStyle/>
           <a:p>
             <a:pPr algn="ctr"/>
+            <a:endParaRPr/>
           </a:p>
         </p:txBody>
       </p:sp>
@@ -10804,7 +12738,7 @@
               <a:spcAft>
                 <a:spcPts val="600"/>
               </a:spcAft>
-              <a:defRPr b="1" sz="1350">
+              <a:defRPr sz="1350" b="1">
                 <a:solidFill>
                   <a:srgbClr val="1B4F72"/>
                 </a:solidFill>
@@ -10918,6 +12852,7 @@
           <a:lstStyle/>
           <a:p>
             <a:pPr algn="ctr"/>
+            <a:endParaRPr/>
           </a:p>
         </p:txBody>
       </p:sp>
@@ -10962,7 +12897,7 @@
               <a:spcAft>
                 <a:spcPts val="600"/>
               </a:spcAft>
-              <a:defRPr b="1" sz="1350">
+              <a:defRPr sz="1350" b="1">
                 <a:solidFill>
                   <a:srgbClr val="0E6655"/>
                 </a:solidFill>
@@ -11043,7 +12978,7 @@
 </file>
 
 <file path=ppt/slides/slide6.xml><?xml version="1.0" encoding="utf-8"?>
-<p:sld xmlns:a="http://schemas.openxmlformats.org/drawingml/2006/main" xmlns:p="http://schemas.openxmlformats.org/presentationml/2006/main" xmlns:r="http://schemas.openxmlformats.org/officeDocument/2006/relationships">
+<p:sld xmlns:a="http://schemas.openxmlformats.org/drawingml/2006/main" xmlns:r="http://schemas.openxmlformats.org/officeDocument/2006/relationships" xmlns:p="http://schemas.openxmlformats.org/presentationml/2006/main">
   <p:cSld>
     <p:spTree>
       <p:nvGrpSpPr>
@@ -11051,7 +12986,14 @@
         <p:cNvGrpSpPr/>
         <p:nvPr/>
       </p:nvGrpSpPr>
-      <p:grpSpPr/>
+      <p:grpSpPr>
+        <a:xfrm>
+          <a:off x="0" y="0"/>
+          <a:ext cx="0" cy="0"/>
+          <a:chOff x="0" y="0"/>
+          <a:chExt cx="0" cy="0"/>
+        </a:xfrm>
+      </p:grpSpPr>
       <p:sp>
         <p:nvSpPr>
           <p:cNvPr id="2" name="Rectangle 1"/>
@@ -11092,6 +13034,7 @@
           <a:lstStyle/>
           <a:p>
             <a:pPr algn="ctr"/>
+            <a:endParaRPr/>
           </a:p>
         </p:txBody>
       </p:sp>
@@ -11240,6 +13183,7 @@
           <a:lstStyle/>
           <a:p>
             <a:pPr algn="ctr"/>
+            <a:endParaRPr/>
           </a:p>
         </p:txBody>
       </p:sp>
@@ -11320,6 +13264,7 @@
           <a:lstStyle/>
           <a:p>
             <a:pPr algn="ctr"/>
+            <a:endParaRPr/>
           </a:p>
         </p:txBody>
       </p:sp>
@@ -11364,7 +13309,7 @@
               <a:spcAft>
                 <a:spcPts val="600"/>
               </a:spcAft>
-              <a:defRPr b="1" sz="1350">
+              <a:defRPr sz="1350" b="1">
                 <a:solidFill>
                   <a:srgbClr val="1B4F72"/>
                 </a:solidFill>
@@ -11493,6 +13438,7 @@
           <a:lstStyle/>
           <a:p>
             <a:pPr algn="ctr"/>
+            <a:endParaRPr/>
           </a:p>
         </p:txBody>
       </p:sp>
@@ -11537,7 +13483,7 @@
               <a:spcAft>
                 <a:spcPts val="600"/>
               </a:spcAft>
-              <a:defRPr b="1" sz="1350">
+              <a:defRPr sz="1350" b="1">
                 <a:solidFill>
                   <a:srgbClr val="1B4F72"/>
                 </a:solidFill>
@@ -11666,6 +13612,7 @@
           <a:lstStyle/>
           <a:p>
             <a:pPr algn="ctr"/>
+            <a:endParaRPr/>
           </a:p>
         </p:txBody>
       </p:sp>
@@ -11692,7 +13639,7 @@
           <a:lstStyle/>
           <a:p>
             <a:pPr>
-              <a:defRPr b="1" sz="1200">
+              <a:defRPr sz="1200" b="1">
                 <a:solidFill>
                   <a:srgbClr val="0E6655"/>
                 </a:solidFill>
@@ -11732,7 +13679,7 @@
 </file>
 
 <file path=ppt/slides/slide7.xml><?xml version="1.0" encoding="utf-8"?>
-<p:sld xmlns:a="http://schemas.openxmlformats.org/drawingml/2006/main" xmlns:p="http://schemas.openxmlformats.org/presentationml/2006/main" xmlns:r="http://schemas.openxmlformats.org/officeDocument/2006/relationships">
+<p:sld xmlns:a="http://schemas.openxmlformats.org/drawingml/2006/main" xmlns:r="http://schemas.openxmlformats.org/officeDocument/2006/relationships" xmlns:p="http://schemas.openxmlformats.org/presentationml/2006/main">
   <p:cSld>
     <p:spTree>
       <p:nvGrpSpPr>
@@ -11740,7 +13687,14 @@
         <p:cNvGrpSpPr/>
         <p:nvPr/>
       </p:nvGrpSpPr>
-      <p:grpSpPr/>
+      <p:grpSpPr>
+        <a:xfrm>
+          <a:off x="0" y="0"/>
+          <a:ext cx="0" cy="0"/>
+          <a:chOff x="0" y="0"/>
+          <a:chExt cx="0" cy="0"/>
+        </a:xfrm>
+      </p:grpSpPr>
       <p:sp>
         <p:nvSpPr>
           <p:cNvPr id="2" name="Rectangle 1"/>
@@ -11781,6 +13735,7 @@
           <a:lstStyle/>
           <a:p>
             <a:pPr algn="ctr"/>
+            <a:endParaRPr/>
           </a:p>
         </p:txBody>
       </p:sp>
@@ -11929,6 +13884,7 @@
           <a:lstStyle/>
           <a:p>
             <a:pPr algn="ctr"/>
+            <a:endParaRPr/>
           </a:p>
         </p:txBody>
       </p:sp>
@@ -12009,6 +13965,7 @@
           <a:lstStyle/>
           <a:p>
             <a:pPr algn="ctr"/>
+            <a:endParaRPr/>
           </a:p>
         </p:txBody>
       </p:sp>
@@ -12053,7 +14010,7 @@
               <a:spcAft>
                 <a:spcPts val="600"/>
               </a:spcAft>
-              <a:defRPr b="1" sz="1350">
+              <a:defRPr sz="1350" b="1">
                 <a:solidFill>
                   <a:srgbClr val="1B4F72"/>
                 </a:solidFill>
@@ -12167,6 +14124,7 @@
           <a:lstStyle/>
           <a:p>
             <a:pPr algn="ctr"/>
+            <a:endParaRPr/>
           </a:p>
         </p:txBody>
       </p:sp>
@@ -12211,7 +14169,7 @@
               <a:spcAft>
                 <a:spcPts val="600"/>
               </a:spcAft>
-              <a:defRPr b="1" sz="1350">
+              <a:defRPr sz="1350" b="1">
                 <a:solidFill>
                   <a:srgbClr val="1B4F72"/>
                 </a:solidFill>
@@ -12325,6 +14283,7 @@
           <a:lstStyle/>
           <a:p>
             <a:pPr algn="ctr"/>
+            <a:endParaRPr/>
           </a:p>
         </p:txBody>
       </p:sp>
@@ -12369,7 +14328,7 @@
               <a:spcAft>
                 <a:spcPts val="600"/>
               </a:spcAft>
-              <a:defRPr b="1" sz="1350">
+              <a:defRPr sz="1350" b="1">
                 <a:solidFill>
                   <a:srgbClr val="1B4F72"/>
                 </a:solidFill>
@@ -12483,6 +14442,7 @@
           <a:lstStyle/>
           <a:p>
             <a:pPr algn="ctr"/>
+            <a:endParaRPr/>
           </a:p>
         </p:txBody>
       </p:sp>
@@ -12509,7 +14469,7 @@
           <a:lstStyle/>
           <a:p>
             <a:pPr>
-              <a:defRPr b="1" sz="1200">
+              <a:defRPr sz="1200" b="1">
                 <a:solidFill>
                   <a:srgbClr val="E65100"/>
                 </a:solidFill>
@@ -12549,7 +14509,7 @@
 </file>
 
 <file path=ppt/slides/slide8.xml><?xml version="1.0" encoding="utf-8"?>
-<p:sld xmlns:a="http://schemas.openxmlformats.org/drawingml/2006/main" xmlns:p="http://schemas.openxmlformats.org/presentationml/2006/main" xmlns:r="http://schemas.openxmlformats.org/officeDocument/2006/relationships">
+<p:sld xmlns:a="http://schemas.openxmlformats.org/drawingml/2006/main" xmlns:r="http://schemas.openxmlformats.org/officeDocument/2006/relationships" xmlns:p="http://schemas.openxmlformats.org/presentationml/2006/main">
   <p:cSld>
     <p:spTree>
       <p:nvGrpSpPr>
@@ -12557,7 +14517,14 @@
         <p:cNvGrpSpPr/>
         <p:nvPr/>
       </p:nvGrpSpPr>
-      <p:grpSpPr/>
+      <p:grpSpPr>
+        <a:xfrm>
+          <a:off x="0" y="0"/>
+          <a:ext cx="0" cy="0"/>
+          <a:chOff x="0" y="0"/>
+          <a:chExt cx="0" cy="0"/>
+        </a:xfrm>
+      </p:grpSpPr>
       <p:sp>
         <p:nvSpPr>
           <p:cNvPr id="2" name="Rectangle 1"/>
@@ -12598,6 +14565,7 @@
           <a:lstStyle/>
           <a:p>
             <a:pPr algn="ctr"/>
+            <a:endParaRPr/>
           </a:p>
         </p:txBody>
       </p:sp>
@@ -12746,6 +14714,7 @@
           <a:lstStyle/>
           <a:p>
             <a:pPr algn="ctr"/>
+            <a:endParaRPr/>
           </a:p>
         </p:txBody>
       </p:sp>
@@ -12826,6 +14795,7 @@
           <a:lstStyle/>
           <a:p>
             <a:pPr algn="ctr"/>
+            <a:endParaRPr/>
           </a:p>
         </p:txBody>
       </p:sp>
@@ -12870,7 +14840,7 @@
               <a:spcAft>
                 <a:spcPts val="600"/>
               </a:spcAft>
-              <a:defRPr b="1" sz="1350">
+              <a:defRPr sz="1350" b="1">
                 <a:solidFill>
                   <a:srgbClr val="1B4F72"/>
                 </a:solidFill>
@@ -12969,6 +14939,7 @@
           <a:lstStyle/>
           <a:p>
             <a:pPr algn="ctr"/>
+            <a:endParaRPr/>
           </a:p>
         </p:txBody>
       </p:sp>
@@ -13013,7 +14984,7 @@
               <a:spcAft>
                 <a:spcPts val="600"/>
               </a:spcAft>
-              <a:defRPr b="1" sz="1350">
+              <a:defRPr sz="1350" b="1">
                 <a:solidFill>
                   <a:srgbClr val="1B4F72"/>
                 </a:solidFill>
@@ -13112,6 +15083,7 @@
           <a:lstStyle/>
           <a:p>
             <a:pPr algn="ctr"/>
+            <a:endParaRPr/>
           </a:p>
         </p:txBody>
       </p:sp>
@@ -13156,7 +15128,7 @@
               <a:spcAft>
                 <a:spcPts val="600"/>
               </a:spcAft>
-              <a:defRPr b="1" sz="1350">
+              <a:defRPr sz="1350" b="1">
                 <a:solidFill>
                   <a:srgbClr val="1B4F72"/>
                 </a:solidFill>
@@ -13255,6 +15227,7 @@
           <a:lstStyle/>
           <a:p>
             <a:pPr algn="ctr"/>
+            <a:endParaRPr/>
           </a:p>
         </p:txBody>
       </p:sp>
@@ -13299,7 +15272,7 @@
               <a:spcAft>
                 <a:spcPts val="600"/>
               </a:spcAft>
-              <a:defRPr b="1" sz="1350">
+              <a:defRPr sz="1350" b="1">
                 <a:solidFill>
                   <a:srgbClr val="1B4F72"/>
                 </a:solidFill>
@@ -13365,7 +15338,7 @@
 </file>
 
 <file path=ppt/slides/slide9.xml><?xml version="1.0" encoding="utf-8"?>
-<p:sld xmlns:a="http://schemas.openxmlformats.org/drawingml/2006/main" xmlns:p="http://schemas.openxmlformats.org/presentationml/2006/main" xmlns:r="http://schemas.openxmlformats.org/officeDocument/2006/relationships">
+<p:sld xmlns:a="http://schemas.openxmlformats.org/drawingml/2006/main" xmlns:r="http://schemas.openxmlformats.org/officeDocument/2006/relationships" xmlns:p="http://schemas.openxmlformats.org/presentationml/2006/main">
   <p:cSld>
     <p:spTree>
       <p:nvGrpSpPr>
@@ -13373,7 +15346,14 @@
         <p:cNvGrpSpPr/>
         <p:nvPr/>
       </p:nvGrpSpPr>
-      <p:grpSpPr/>
+      <p:grpSpPr>
+        <a:xfrm>
+          <a:off x="0" y="0"/>
+          <a:ext cx="0" cy="0"/>
+          <a:chOff x="0" y="0"/>
+          <a:chExt cx="0" cy="0"/>
+        </a:xfrm>
+      </p:grpSpPr>
       <p:sp>
         <p:nvSpPr>
           <p:cNvPr id="2" name="Rectangle 1"/>
@@ -13414,6 +15394,7 @@
           <a:lstStyle/>
           <a:p>
             <a:pPr algn="ctr"/>
+            <a:endParaRPr/>
           </a:p>
         </p:txBody>
       </p:sp>
@@ -13562,6 +15543,7 @@
           <a:lstStyle/>
           <a:p>
             <a:pPr algn="ctr"/>
+            <a:endParaRPr/>
           </a:p>
         </p:txBody>
       </p:sp>
@@ -13642,6 +15624,7 @@
           <a:lstStyle/>
           <a:p>
             <a:pPr algn="ctr"/>
+            <a:endParaRPr/>
           </a:p>
         </p:txBody>
       </p:sp>
@@ -13668,7 +15651,7 @@
           <a:lstStyle/>
           <a:p>
             <a:pPr algn="ctr">
-              <a:defRPr b="1" sz="1050">
+              <a:defRPr sz="1050" b="1">
                 <a:solidFill>
                   <a:srgbClr val="1B4F72"/>
                 </a:solidFill>
@@ -13746,6 +15729,7 @@
           <a:lstStyle/>
           <a:p>
             <a:pPr algn="ctr"/>
+            <a:endParaRPr/>
           </a:p>
         </p:txBody>
       </p:sp>
@@ -13772,7 +15756,7 @@
           <a:lstStyle/>
           <a:p>
             <a:pPr algn="ctr">
-              <a:defRPr b="1" sz="1050">
+              <a:defRPr sz="1050" b="1">
                 <a:solidFill>
                   <a:srgbClr val="1B4F72"/>
                 </a:solidFill>
@@ -13850,6 +15834,7 @@
           <a:lstStyle/>
           <a:p>
             <a:pPr algn="ctr"/>
+            <a:endParaRPr/>
           </a:p>
         </p:txBody>
       </p:sp>
@@ -13894,7 +15879,7 @@
               <a:spcAft>
                 <a:spcPts val="600"/>
               </a:spcAft>
-              <a:defRPr b="1" sz="1350">
+              <a:defRPr sz="1350" b="1">
                 <a:solidFill>
                   <a:srgbClr val="1B4F72"/>
                 </a:solidFill>
@@ -14008,6 +15993,7 @@
           <a:lstStyle/>
           <a:p>
             <a:pPr algn="ctr"/>
+            <a:endParaRPr/>
           </a:p>
         </p:txBody>
       </p:sp>
@@ -14052,7 +16038,7 @@
               <a:spcAft>
                 <a:spcPts val="600"/>
               </a:spcAft>
-              <a:defRPr b="1" sz="1350">
+              <a:defRPr sz="1350" b="1">
                 <a:solidFill>
                   <a:srgbClr val="0E6655"/>
                 </a:solidFill>

</xml_diff>